<commit_message>
Welle 3: VA02 kuratiertes Deck + 2 Schaubilder (Web/Admin/Workbook)
Co-Authored-By: Claude Fable 5 <noreply@anthropic.com>
</commit_message>
<xml_diff>
--- a/protected-downloads/praesentation/VA02.pptx
+++ b/protected-downloads/praesentation/VA02.pptx
@@ -13,6 +13,14 @@
     <p:sldId id="261" r:id="rId13"/>
     <p:sldId id="262" r:id="rId14"/>
     <p:sldId id="263" r:id="rId15"/>
+    <p:sldId id="264" r:id="rId16"/>
+    <p:sldId id="265" r:id="rId17"/>
+    <p:sldId id="266" r:id="rId18"/>
+    <p:sldId id="267" r:id="rId19"/>
+    <p:sldId id="268" r:id="rId20"/>
+    <p:sldId id="269" r:id="rId21"/>
+    <p:sldId id="270" r:id="rId22"/>
+    <p:sldId id="271" r:id="rId23"/>
   </p:sldIdLst>
   <p:sldSz cx="12188952" cy="6858000" type="screen4x3"/>
   <p:notesSz cx="6858000" cy="9144000"/>
@@ -579,7 +587,7 @@
           <a:lstStyle/>
           <a:p>
             <a:r>
-              <a:t>Siehe Trainerhandbuch (Sektion 3) für Moderationshinweise, Timing und erwartete Teilnehmerreaktionen.</a:t>
+              <a:t>Anknüpfung an VA01 (Kreditakte): Was kam seitdem in der Praxis vor? Aktivierungsfrage: „Welche Sicherheit ist in Ihrem Haus am häufigsten?"</a:t>
             </a:r>
           </a:p>
         </p:txBody>
@@ -649,7 +657,7 @@
           <a:lstStyle/>
           <a:p>
             <a:r>
-              <a:t>Siehe Trainerhandbuch (Sektion 3) für Moderationshinweise, Timing und erwartete Teilnehmerreaktionen.</a:t>
+              <a:t>Schwerpunkt Grundschuld (Rang im Grundbuch) und Bürgschaft (Schriftform § 766 BGB) – die zwei häufigsten Formfehlerquellen.</a:t>
             </a:r>
           </a:p>
         </p:txBody>
@@ -719,22 +727,7 @@
           <a:lstStyle/>
           <a:p>
             <a:r>
-              <a:t>AB-2 Musterlösung (Trainer-Version)</a:t>
-            </a:r>
-          </a:p>
-          <a:p>
-            <a:r>
-              <a:t>Erfüllt: Kreditvertrag (✓), Bürgschaft (✓), § 18 (✓). Offen: Grundschuld nur im 2. Rang (vereinbart war werthaltige Besicherung; der 1. Rang der Fremdbank schmälert die Sicherheit erheblich) und fehlender Eigenmittelnachweis (Auflage). Auszahlung ist nicht freigabereif. Beide Punkte sind zu dokumentieren und an Berater sowie Marktfolge zu eskalieren: Rang/Besicherung muss mit Berater und Marktfolge geklärt werden (ggf. Rangrücktritt, Nachbesicherung); Eigenmittelnachweis ist beim Kunden anzufordern. Die Entscheidung, die Auszahlung anzuhalten, treffen Berater oder Marktfolge – nicht die Assistenz eigenständig.</a:t>
-            </a:r>
-          </a:p>
-          <a:p>
-            <a:r>
-              <a:t>Kernbefund: Formal „vorhanden" reicht nicht – die Qualität der Sicherheit (Rang) und die Auflagenerfüllung entscheiden. Der 2. Rang ist der typische, leicht zu übersehende Mangel. Die Assistenz erkennt ihn, dokumentiert ihn und eskaliert – die Freigabeentscheidung liegt beim Berater oder der Marktfolge.</a:t>
-            </a:r>
-          </a:p>
-          <a:p>
-            <a:r>
-              <a:t>Trainer-Hinweis: Der Rang ist der Lernkern. Viele prüfen nur „Grundschuld eingetragen: ja" und übersehen den Rang. Betonen: Es geht nicht um juristische Bewertung (das ist Marktfolge/Recht), sondern ums Erkennen und Eskalieren des offenen Punkts. Ebenso wichtig: Klarstellen, dass die Assistenz nie eigenständig eine Auszahlung zurückstellt – sie informiert und eskaliert, die Entscheidung trifft der Berater oder die Marktfolge.</a:t>
+              <a:t>Klare Rollenbotschaft: Fehlt eine Voraussetzung, wird sie als offener Punkt behandelt und zur Klärung an Berater oder Marktfolge gegeben – nicht selbst entschieden.</a:t>
             </a:r>
           </a:p>
         </p:txBody>
@@ -804,7 +797,297 @@
           <a:lstStyle/>
           <a:p>
             <a:r>
-              <a:t>Siehe Trainerhandbuch (Sektion 3) für Moderationshinweise, Timing und erwartete Teilnehmerreaktionen.</a:t>
+              <a:t>Fall vorstellen, dann selbst prüfen lassen (Einzel-/Partnerarbeit). Trainer beobachtet ohne einzugreifen.</a:t>
+            </a:r>
+          </a:p>
+        </p:txBody>
+      </p:sp>
+      <p:sp>
+        <p:nvSpPr>
+          <p:cNvPr id="4" name="Slide Number Placeholder 3"/>
+          <p:cNvSpPr>
+            <a:spLocks noGrp="1"/>
+          </p:cNvSpPr>
+          <p:nvPr>
+            <p:ph type="sldNum" idx="5" sz="quarter"/>
+          </p:nvPr>
+        </p:nvSpPr>
+        <p:spPr/>
+      </p:sp>
+    </p:spTree>
+  </p:cSld>
+  <p:clrMapOvr>
+    <a:masterClrMapping/>
+  </p:clrMapOvr>
+</p:notes>
+</file>
+
+<file path=ppt/notesSlides/notesSlide6.xml><?xml version="1.0" encoding="utf-8"?>
+<p:notes xmlns:a="http://schemas.openxmlformats.org/drawingml/2006/main" xmlns:p="http://schemas.openxmlformats.org/presentationml/2006/main" xmlns:r="http://schemas.openxmlformats.org/officeDocument/2006/relationships">
+  <p:cSld>
+    <p:spTree>
+      <p:nvGrpSpPr>
+        <p:cNvPr id="1" name=""/>
+        <p:cNvGrpSpPr/>
+        <p:nvPr/>
+      </p:nvGrpSpPr>
+      <p:grpSpPr>
+        <a:xfrm>
+          <a:off x="0" y="0"/>
+          <a:ext cx="0" cy="0"/>
+          <a:chOff x="0" y="0"/>
+          <a:chExt cx="0" cy="0"/>
+        </a:xfrm>
+      </p:grpSpPr>
+      <p:sp>
+        <p:nvSpPr>
+          <p:cNvPr id="2" name="Slide Image Placeholder 1"/>
+          <p:cNvSpPr>
+            <a:spLocks noGrp="1"/>
+          </p:cNvSpPr>
+          <p:nvPr>
+            <p:ph type="sldImg" idx="2"/>
+          </p:nvPr>
+        </p:nvSpPr>
+        <p:spPr/>
+      </p:sp>
+      <p:sp>
+        <p:nvSpPr>
+          <p:cNvPr id="3" name="Notes Placeholder 2"/>
+          <p:cNvSpPr>
+            <a:spLocks noGrp="1"/>
+          </p:cNvSpPr>
+          <p:nvPr>
+            <p:ph type="body" idx="3" sz="quarter"/>
+          </p:nvPr>
+        </p:nvSpPr>
+        <p:spPr/>
+        <p:txBody>
+          <a:bodyPr/>
+          <a:lstStyle/>
+          <a:p>
+            <a:r>
+              <a:t>Kernbefund des Falls: Grundschuld nur im 2. Rang (1. Rang Fremdbank 250 TEUR) und Eigenmittelnachweis 50 TEUR fehlt – beides blockiert die Auszahlung. Eskalieren ist Kompetenz, nicht Schwäche.</a:t>
+            </a:r>
+          </a:p>
+        </p:txBody>
+      </p:sp>
+      <p:sp>
+        <p:nvSpPr>
+          <p:cNvPr id="4" name="Slide Number Placeholder 3"/>
+          <p:cNvSpPr>
+            <a:spLocks noGrp="1"/>
+          </p:cNvSpPr>
+          <p:nvPr>
+            <p:ph type="sldNum" idx="5" sz="quarter"/>
+          </p:nvPr>
+        </p:nvSpPr>
+        <p:spPr/>
+      </p:sp>
+    </p:spTree>
+  </p:cSld>
+  <p:clrMapOvr>
+    <a:masterClrMapping/>
+  </p:clrMapOvr>
+</p:notes>
+</file>
+
+<file path=ppt/notesSlides/notesSlide7.xml><?xml version="1.0" encoding="utf-8"?>
+<p:notes xmlns:a="http://schemas.openxmlformats.org/drawingml/2006/main" xmlns:p="http://schemas.openxmlformats.org/presentationml/2006/main" xmlns:r="http://schemas.openxmlformats.org/officeDocument/2006/relationships">
+  <p:cSld>
+    <p:spTree>
+      <p:nvGrpSpPr>
+        <p:cNvPr id="1" name=""/>
+        <p:cNvGrpSpPr/>
+        <p:nvPr/>
+      </p:nvGrpSpPr>
+      <p:grpSpPr>
+        <a:xfrm>
+          <a:off x="0" y="0"/>
+          <a:ext cx="0" cy="0"/>
+          <a:chOff x="0" y="0"/>
+          <a:chExt cx="0" cy="0"/>
+        </a:xfrm>
+      </p:grpSpPr>
+      <p:sp>
+        <p:nvSpPr>
+          <p:cNvPr id="2" name="Slide Image Placeholder 1"/>
+          <p:cNvSpPr>
+            <a:spLocks noGrp="1"/>
+          </p:cNvSpPr>
+          <p:nvPr>
+            <p:ph type="sldImg" idx="2"/>
+          </p:nvPr>
+        </p:nvSpPr>
+        <p:spPr/>
+      </p:sp>
+      <p:sp>
+        <p:nvSpPr>
+          <p:cNvPr id="3" name="Notes Placeholder 2"/>
+          <p:cNvSpPr>
+            <a:spLocks noGrp="1"/>
+          </p:cNvSpPr>
+          <p:nvPr>
+            <p:ph type="body" idx="3" sz="quarter"/>
+          </p:nvPr>
+        </p:nvSpPr>
+        <p:spPr/>
+        <p:txBody>
+          <a:bodyPr/>
+          <a:lstStyle/>
+          <a:p>
+            <a:r>
+              <a:t>AB-2/AB-3 Musterlösung (Trainer-Version)</a:t>
+            </a:r>
+          </a:p>
+          <a:p>
+            <a:r>
+              <a:t>Blockierend: Grundschuld im 2. statt vereinbarten Rang; fehlender Eigenmittelnachweis (Auflage). Beide vor Auszahlung zu klären.</a:t>
+            </a:r>
+          </a:p>
+          <a:p>
+            <a:r>
+              <a:t>Trainer-Hinweis: Ziel ist die Rollensicherheit „erkennen–dokumentieren–eskalieren", nicht die juristische Tiefe des Grundbuchrechts.</a:t>
+            </a:r>
+          </a:p>
+        </p:txBody>
+      </p:sp>
+      <p:sp>
+        <p:nvSpPr>
+          <p:cNvPr id="4" name="Slide Number Placeholder 3"/>
+          <p:cNvSpPr>
+            <a:spLocks noGrp="1"/>
+          </p:cNvSpPr>
+          <p:nvPr>
+            <p:ph type="sldNum" idx="5" sz="quarter"/>
+          </p:nvPr>
+        </p:nvSpPr>
+        <p:spPr/>
+      </p:sp>
+    </p:spTree>
+  </p:cSld>
+  <p:clrMapOvr>
+    <a:masterClrMapping/>
+  </p:clrMapOvr>
+</p:notes>
+</file>
+
+<file path=ppt/notesSlides/notesSlide8.xml><?xml version="1.0" encoding="utf-8"?>
+<p:notes xmlns:a="http://schemas.openxmlformats.org/drawingml/2006/main" xmlns:p="http://schemas.openxmlformats.org/presentationml/2006/main" xmlns:r="http://schemas.openxmlformats.org/officeDocument/2006/relationships">
+  <p:cSld>
+    <p:spTree>
+      <p:nvGrpSpPr>
+        <p:cNvPr id="1" name=""/>
+        <p:cNvGrpSpPr/>
+        <p:nvPr/>
+      </p:nvGrpSpPr>
+      <p:grpSpPr>
+        <a:xfrm>
+          <a:off x="0" y="0"/>
+          <a:ext cx="0" cy="0"/>
+          <a:chOff x="0" y="0"/>
+          <a:chExt cx="0" cy="0"/>
+        </a:xfrm>
+      </p:grpSpPr>
+      <p:sp>
+        <p:nvSpPr>
+          <p:cNvPr id="2" name="Slide Image Placeholder 1"/>
+          <p:cNvSpPr>
+            <a:spLocks noGrp="1"/>
+          </p:cNvSpPr>
+          <p:nvPr>
+            <p:ph type="sldImg" idx="2"/>
+          </p:nvPr>
+        </p:nvSpPr>
+        <p:spPr/>
+      </p:sp>
+      <p:sp>
+        <p:nvSpPr>
+          <p:cNvPr id="3" name="Notes Placeholder 2"/>
+          <p:cNvSpPr>
+            <a:spLocks noGrp="1"/>
+          </p:cNvSpPr>
+          <p:nvPr>
+            <p:ph type="body" idx="3" sz="quarter"/>
+          </p:nvPr>
+        </p:nvSpPr>
+        <p:spPr/>
+        <p:txBody>
+          <a:bodyPr/>
+          <a:lstStyle/>
+          <a:p>
+            <a:r>
+              <a:t>Überleitung zum Transfer: die Prüfkarte AB-5 ist das Werkzeug für die nächste Auszahlung.</a:t>
+            </a:r>
+          </a:p>
+        </p:txBody>
+      </p:sp>
+      <p:sp>
+        <p:nvSpPr>
+          <p:cNvPr id="4" name="Slide Number Placeholder 3"/>
+          <p:cNvSpPr>
+            <a:spLocks noGrp="1"/>
+          </p:cNvSpPr>
+          <p:nvPr>
+            <p:ph type="sldNum" idx="5" sz="quarter"/>
+          </p:nvPr>
+        </p:nvSpPr>
+        <p:spPr/>
+      </p:sp>
+    </p:spTree>
+  </p:cSld>
+  <p:clrMapOvr>
+    <a:masterClrMapping/>
+  </p:clrMapOvr>
+</p:notes>
+</file>
+
+<file path=ppt/notesSlides/notesSlide9.xml><?xml version="1.0" encoding="utf-8"?>
+<p:notes xmlns:a="http://schemas.openxmlformats.org/drawingml/2006/main" xmlns:p="http://schemas.openxmlformats.org/presentationml/2006/main" xmlns:r="http://schemas.openxmlformats.org/officeDocument/2006/relationships">
+  <p:cSld>
+    <p:spTree>
+      <p:nvGrpSpPr>
+        <p:cNvPr id="1" name=""/>
+        <p:cNvGrpSpPr/>
+        <p:nvPr/>
+      </p:nvGrpSpPr>
+      <p:grpSpPr>
+        <a:xfrm>
+          <a:off x="0" y="0"/>
+          <a:ext cx="0" cy="0"/>
+          <a:chOff x="0" y="0"/>
+          <a:chExt cx="0" cy="0"/>
+        </a:xfrm>
+      </p:grpSpPr>
+      <p:sp>
+        <p:nvSpPr>
+          <p:cNvPr id="2" name="Slide Image Placeholder 1"/>
+          <p:cNvSpPr>
+            <a:spLocks noGrp="1"/>
+          </p:cNvSpPr>
+          <p:nvPr>
+            <p:ph type="sldImg" idx="2"/>
+          </p:nvPr>
+        </p:nvSpPr>
+        <p:spPr/>
+      </p:sp>
+      <p:sp>
+        <p:nvSpPr>
+          <p:cNvPr id="3" name="Notes Placeholder 2"/>
+          <p:cNvSpPr>
+            <a:spLocks noGrp="1"/>
+          </p:cNvSpPr>
+          <p:nvPr>
+            <p:ph type="body" idx="3" sz="quarter"/>
+          </p:nvPr>
+        </p:nvSpPr>
+        <p:spPr/>
+        <p:txBody>
+          <a:bodyPr/>
+          <a:lstStyle/>
+          <a:p>
+            <a:r>
+              <a:t>Fragen 1 und 3 im Plenum besprechen. Kernbotschaft: Eskalieren ist Kompetenz, nicht Schwäche.</a:t>
             </a:r>
           </a:p>
         </p:txBody>
@@ -4375,6 +4658,2810 @@
 </p:sld>
 </file>
 
+<file path=ppt/slides/slide10.xml><?xml version="1.0" encoding="utf-8"?>
+<p:sld xmlns:a="http://schemas.openxmlformats.org/drawingml/2006/main" xmlns:p="http://schemas.openxmlformats.org/presentationml/2006/main" xmlns:r="http://schemas.openxmlformats.org/officeDocument/2006/relationships">
+  <p:cSld>
+    <p:spTree>
+      <p:nvGrpSpPr>
+        <p:cNvPr id="1" name=""/>
+        <p:cNvGrpSpPr/>
+        <p:nvPr/>
+      </p:nvGrpSpPr>
+      <p:grpSpPr/>
+      <p:sp>
+        <p:nvSpPr>
+          <p:cNvPr id="2" name="Rectangle 1"/>
+          <p:cNvSpPr/>
+          <p:nvPr/>
+        </p:nvSpPr>
+        <p:spPr>
+          <a:xfrm>
+            <a:off x="0" y="0"/>
+            <a:ext cx="12188952" cy="6858000"/>
+          </a:xfrm>
+          <a:prstGeom prst="rect">
+            <a:avLst/>
+          </a:prstGeom>
+          <a:solidFill>
+            <a:srgbClr val="FFFFFF"/>
+          </a:solidFill>
+          <a:ln>
+            <a:noFill/>
+          </a:ln>
+        </p:spPr>
+        <p:style>
+          <a:lnRef idx="1">
+            <a:schemeClr val="accent1"/>
+          </a:lnRef>
+          <a:fillRef idx="3">
+            <a:schemeClr val="accent1"/>
+          </a:fillRef>
+          <a:effectRef idx="2">
+            <a:schemeClr val="accent1"/>
+          </a:effectRef>
+          <a:fontRef idx="minor">
+            <a:schemeClr val="lt1"/>
+          </a:fontRef>
+        </p:style>
+        <p:txBody>
+          <a:bodyPr rtlCol="0" anchor="ctr"/>
+          <a:lstStyle/>
+          <a:p>
+            <a:pPr algn="ctr"/>
+          </a:p>
+        </p:txBody>
+      </p:sp>
+      <p:sp>
+        <p:nvSpPr>
+          <p:cNvPr id="3" name="Rectangle 2"/>
+          <p:cNvSpPr/>
+          <p:nvPr/>
+        </p:nvSpPr>
+        <p:spPr>
+          <a:xfrm>
+            <a:off x="0" y="0"/>
+            <a:ext cx="12188952" cy="50292"/>
+          </a:xfrm>
+          <a:prstGeom prst="rect">
+            <a:avLst/>
+          </a:prstGeom>
+          <a:solidFill>
+            <a:srgbClr val="1F2C56"/>
+          </a:solidFill>
+          <a:ln>
+            <a:noFill/>
+          </a:ln>
+        </p:spPr>
+        <p:style>
+          <a:lnRef idx="1">
+            <a:schemeClr val="accent1"/>
+          </a:lnRef>
+          <a:fillRef idx="3">
+            <a:schemeClr val="accent1"/>
+          </a:fillRef>
+          <a:effectRef idx="2">
+            <a:schemeClr val="accent1"/>
+          </a:effectRef>
+          <a:fontRef idx="minor">
+            <a:schemeClr val="lt1"/>
+          </a:fontRef>
+        </p:style>
+        <p:txBody>
+          <a:bodyPr rtlCol="0" anchor="ctr"/>
+          <a:lstStyle/>
+          <a:p>
+            <a:pPr algn="ctr"/>
+          </a:p>
+        </p:txBody>
+      </p:sp>
+      <p:sp>
+        <p:nvSpPr>
+          <p:cNvPr id="4" name="TextBox 3"/>
+          <p:cNvSpPr txBox="1"/>
+          <p:nvPr/>
+        </p:nvSpPr>
+        <p:spPr>
+          <a:xfrm>
+            <a:off x="685800" y="109728"/>
+            <a:ext cx="10817352" cy="228600"/>
+          </a:xfrm>
+          <a:prstGeom prst="rect">
+            <a:avLst/>
+          </a:prstGeom>
+          <a:noFill/>
+        </p:spPr>
+        <p:txBody>
+          <a:bodyPr wrap="none">
+            <a:spAutoFit/>
+          </a:bodyPr>
+          <a:lstStyle/>
+          <a:p>
+            <a:pPr algn="l"/>
+            <a:r>
+              <a:rPr sz="750">
+                <a:solidFill>
+                  <a:srgbClr val="78808C"/>
+                </a:solidFill>
+                <a:latin typeface="Consolas"/>
+              </a:rPr>
+              <a:t>VA02  ·  SCHAUBILD</a:t>
+            </a:r>
+          </a:p>
+        </p:txBody>
+      </p:sp>
+      <p:sp>
+        <p:nvSpPr>
+          <p:cNvPr id="5" name="TextBox 4"/>
+          <p:cNvSpPr txBox="1"/>
+          <p:nvPr/>
+        </p:nvSpPr>
+        <p:spPr>
+          <a:xfrm>
+            <a:off x="685800" y="502920"/>
+            <a:ext cx="10817352" cy="594360"/>
+          </a:xfrm>
+          <a:prstGeom prst="rect">
+            <a:avLst/>
+          </a:prstGeom>
+          <a:noFill/>
+        </p:spPr>
+        <p:txBody>
+          <a:bodyPr wrap="square">
+            <a:spAutoFit/>
+          </a:bodyPr>
+          <a:lstStyle/>
+          <a:p>
+            <a:pPr algn="l"/>
+            <a:r>
+              <a:rPr sz="2000" b="1" i="0">
+                <a:solidFill>
+                  <a:srgbClr val="1F2C56"/>
+                </a:solidFill>
+                <a:latin typeface="Arial"/>
+              </a:rPr>
+              <a:t>Auszahlungsvoraussetzungen</a:t>
+            </a:r>
+          </a:p>
+        </p:txBody>
+      </p:sp>
+      <p:sp>
+        <p:nvSpPr>
+          <p:cNvPr id="6" name="Rectangle 5"/>
+          <p:cNvSpPr/>
+          <p:nvPr/>
+        </p:nvSpPr>
+        <p:spPr>
+          <a:xfrm>
+            <a:off x="685800" y="1143000"/>
+            <a:ext cx="10817352" cy="25400"/>
+          </a:xfrm>
+          <a:prstGeom prst="rect">
+            <a:avLst/>
+          </a:prstGeom>
+          <a:solidFill>
+            <a:srgbClr val="D9C089"/>
+          </a:solidFill>
+          <a:ln>
+            <a:noFill/>
+          </a:ln>
+        </p:spPr>
+        <p:style>
+          <a:lnRef idx="1">
+            <a:schemeClr val="accent1"/>
+          </a:lnRef>
+          <a:fillRef idx="3">
+            <a:schemeClr val="accent1"/>
+          </a:fillRef>
+          <a:effectRef idx="2">
+            <a:schemeClr val="accent1"/>
+          </a:effectRef>
+          <a:fontRef idx="minor">
+            <a:schemeClr val="lt1"/>
+          </a:fontRef>
+        </p:style>
+        <p:txBody>
+          <a:bodyPr rtlCol="0" anchor="ctr"/>
+          <a:lstStyle/>
+          <a:p>
+            <a:pPr algn="ctr"/>
+          </a:p>
+        </p:txBody>
+      </p:sp>
+      <p:pic>
+        <p:nvPicPr>
+          <p:cNvPr id="7" name="Picture 6" descr="image.png"/>
+          <p:cNvPicPr>
+            <a:picLocks noChangeAspect="1"/>
+          </p:cNvPicPr>
+          <p:nvPr/>
+        </p:nvPicPr>
+        <p:blipFill>
+          <a:blip r:embed="rId2"/>
+          <a:stretch>
+            <a:fillRect/>
+          </a:stretch>
+        </p:blipFill>
+        <p:spPr>
+          <a:xfrm>
+            <a:off x="2009463" y="1325880"/>
+            <a:ext cx="8170026" cy="4937760"/>
+          </a:xfrm>
+          <a:prstGeom prst="rect">
+            <a:avLst/>
+          </a:prstGeom>
+        </p:spPr>
+      </p:pic>
+      <p:sp>
+        <p:nvSpPr>
+          <p:cNvPr id="8" name="Rectangle 7"/>
+          <p:cNvSpPr/>
+          <p:nvPr/>
+        </p:nvSpPr>
+        <p:spPr>
+          <a:xfrm>
+            <a:off x="0" y="6510528"/>
+            <a:ext cx="12188952" cy="347472"/>
+          </a:xfrm>
+          <a:prstGeom prst="rect">
+            <a:avLst/>
+          </a:prstGeom>
+          <a:solidFill>
+            <a:srgbClr val="0A1937"/>
+          </a:solidFill>
+          <a:ln>
+            <a:noFill/>
+          </a:ln>
+        </p:spPr>
+        <p:style>
+          <a:lnRef idx="1">
+            <a:schemeClr val="accent1"/>
+          </a:lnRef>
+          <a:fillRef idx="3">
+            <a:schemeClr val="accent1"/>
+          </a:fillRef>
+          <a:effectRef idx="2">
+            <a:schemeClr val="accent1"/>
+          </a:effectRef>
+          <a:fontRef idx="minor">
+            <a:schemeClr val="lt1"/>
+          </a:fontRef>
+        </p:style>
+        <p:txBody>
+          <a:bodyPr rtlCol="0" anchor="ctr"/>
+          <a:lstStyle/>
+          <a:p>
+            <a:pPr algn="ctr"/>
+          </a:p>
+        </p:txBody>
+      </p:sp>
+      <p:sp>
+        <p:nvSpPr>
+          <p:cNvPr id="9" name="TextBox 8"/>
+          <p:cNvSpPr txBox="1"/>
+          <p:nvPr/>
+        </p:nvSpPr>
+        <p:spPr>
+          <a:xfrm>
+            <a:off x="685800" y="6583680"/>
+            <a:ext cx="6490411" cy="256032"/>
+          </a:xfrm>
+          <a:prstGeom prst="rect">
+            <a:avLst/>
+          </a:prstGeom>
+          <a:noFill/>
+        </p:spPr>
+        <p:txBody>
+          <a:bodyPr wrap="none">
+            <a:spAutoFit/>
+          </a:bodyPr>
+          <a:lstStyle/>
+          <a:p>
+            <a:pPr algn="l"/>
+            <a:r>
+              <a:rPr sz="700">
+                <a:solidFill>
+                  <a:srgbClr val="A0B4D2"/>
+                </a:solidFill>
+                <a:latin typeface="Consolas"/>
+              </a:rPr>
+              <a:t>FKB Campus  ·  VA02</a:t>
+            </a:r>
+          </a:p>
+        </p:txBody>
+      </p:sp>
+      <p:sp>
+        <p:nvSpPr>
+          <p:cNvPr id="10" name="TextBox 9"/>
+          <p:cNvSpPr txBox="1"/>
+          <p:nvPr/>
+        </p:nvSpPr>
+        <p:spPr>
+          <a:xfrm>
+            <a:off x="7176211" y="6583680"/>
+            <a:ext cx="4326940" cy="256032"/>
+          </a:xfrm>
+          <a:prstGeom prst="rect">
+            <a:avLst/>
+          </a:prstGeom>
+          <a:noFill/>
+        </p:spPr>
+        <p:txBody>
+          <a:bodyPr wrap="none">
+            <a:spAutoFit/>
+          </a:bodyPr>
+          <a:lstStyle/>
+          <a:p>
+            <a:pPr algn="r"/>
+            <a:r>
+              <a:rPr sz="700">
+                <a:solidFill>
+                  <a:srgbClr val="A0B4D2"/>
+                </a:solidFill>
+                <a:latin typeface="Consolas"/>
+              </a:rPr>
+              <a:t>Schaubild</a:t>
+            </a:r>
+          </a:p>
+        </p:txBody>
+      </p:sp>
+    </p:spTree>
+  </p:cSld>
+  <p:clrMapOvr>
+    <a:masterClrMapping/>
+  </p:clrMapOvr>
+</p:sld>
+</file>
+
+<file path=ppt/slides/slide11.xml><?xml version="1.0" encoding="utf-8"?>
+<p:sld xmlns:a="http://schemas.openxmlformats.org/drawingml/2006/main" xmlns:p="http://schemas.openxmlformats.org/presentationml/2006/main" xmlns:r="http://schemas.openxmlformats.org/officeDocument/2006/relationships">
+  <p:cSld>
+    <p:spTree>
+      <p:nvGrpSpPr>
+        <p:cNvPr id="1" name=""/>
+        <p:cNvGrpSpPr/>
+        <p:nvPr/>
+      </p:nvGrpSpPr>
+      <p:grpSpPr/>
+      <p:sp>
+        <p:nvSpPr>
+          <p:cNvPr id="2" name="Rectangle 1"/>
+          <p:cNvSpPr/>
+          <p:nvPr/>
+        </p:nvSpPr>
+        <p:spPr>
+          <a:xfrm>
+            <a:off x="0" y="0"/>
+            <a:ext cx="12188952" cy="6858000"/>
+          </a:xfrm>
+          <a:prstGeom prst="rect">
+            <a:avLst/>
+          </a:prstGeom>
+          <a:solidFill>
+            <a:srgbClr val="1F2C56"/>
+          </a:solidFill>
+          <a:ln>
+            <a:noFill/>
+          </a:ln>
+        </p:spPr>
+        <p:style>
+          <a:lnRef idx="1">
+            <a:schemeClr val="accent1"/>
+          </a:lnRef>
+          <a:fillRef idx="3">
+            <a:schemeClr val="accent1"/>
+          </a:fillRef>
+          <a:effectRef idx="2">
+            <a:schemeClr val="accent1"/>
+          </a:effectRef>
+          <a:fontRef idx="minor">
+            <a:schemeClr val="lt1"/>
+          </a:fontRef>
+        </p:style>
+        <p:txBody>
+          <a:bodyPr rtlCol="0" anchor="ctr"/>
+          <a:lstStyle/>
+          <a:p>
+            <a:pPr algn="ctr"/>
+          </a:p>
+        </p:txBody>
+      </p:sp>
+      <p:sp>
+        <p:nvSpPr>
+          <p:cNvPr id="3" name="TextBox 2"/>
+          <p:cNvSpPr txBox="1"/>
+          <p:nvPr/>
+        </p:nvSpPr>
+        <p:spPr>
+          <a:xfrm>
+            <a:off x="685800" y="2377440"/>
+            <a:ext cx="10817352" cy="365760"/>
+          </a:xfrm>
+          <a:prstGeom prst="rect">
+            <a:avLst/>
+          </a:prstGeom>
+          <a:noFill/>
+        </p:spPr>
+        <p:txBody>
+          <a:bodyPr wrap="none">
+            <a:spAutoFit/>
+          </a:bodyPr>
+          <a:lstStyle/>
+          <a:p>
+            <a:pPr algn="l"/>
+            <a:r>
+              <a:rPr sz="1200">
+                <a:solidFill>
+                  <a:srgbClr val="D9C089"/>
+                </a:solidFill>
+                <a:latin typeface="Consolas"/>
+              </a:rPr>
+              <a:t>00:30–01:20</a:t>
+            </a:r>
+          </a:p>
+        </p:txBody>
+      </p:sp>
+      <p:sp>
+        <p:nvSpPr>
+          <p:cNvPr id="4" name="Rectangle 3"/>
+          <p:cNvSpPr/>
+          <p:nvPr/>
+        </p:nvSpPr>
+        <p:spPr>
+          <a:xfrm>
+            <a:off x="685800" y="2788920"/>
+            <a:ext cx="548640" cy="38100"/>
+          </a:xfrm>
+          <a:prstGeom prst="rect">
+            <a:avLst/>
+          </a:prstGeom>
+          <a:solidFill>
+            <a:srgbClr val="D9C089"/>
+          </a:solidFill>
+          <a:ln>
+            <a:noFill/>
+          </a:ln>
+        </p:spPr>
+        <p:style>
+          <a:lnRef idx="1">
+            <a:schemeClr val="accent1"/>
+          </a:lnRef>
+          <a:fillRef idx="3">
+            <a:schemeClr val="accent1"/>
+          </a:fillRef>
+          <a:effectRef idx="2">
+            <a:schemeClr val="accent1"/>
+          </a:effectRef>
+          <a:fontRef idx="minor">
+            <a:schemeClr val="lt1"/>
+          </a:fontRef>
+        </p:style>
+        <p:txBody>
+          <a:bodyPr rtlCol="0" anchor="ctr"/>
+          <a:lstStyle/>
+          <a:p>
+            <a:pPr algn="ctr"/>
+          </a:p>
+        </p:txBody>
+      </p:sp>
+      <p:sp>
+        <p:nvSpPr>
+          <p:cNvPr id="5" name="TextBox 4"/>
+          <p:cNvSpPr txBox="1"/>
+          <p:nvPr/>
+        </p:nvSpPr>
+        <p:spPr>
+          <a:xfrm>
+            <a:off x="685800" y="3017520"/>
+            <a:ext cx="10817352" cy="1463040"/>
+          </a:xfrm>
+          <a:prstGeom prst="rect">
+            <a:avLst/>
+          </a:prstGeom>
+          <a:noFill/>
+        </p:spPr>
+        <p:txBody>
+          <a:bodyPr wrap="square">
+            <a:spAutoFit/>
+          </a:bodyPr>
+          <a:lstStyle/>
+          <a:p>
+            <a:pPr algn="l"/>
+            <a:r>
+              <a:rPr sz="4000" b="1" i="0">
+                <a:solidFill>
+                  <a:srgbClr val="FFFFFF"/>
+                </a:solidFill>
+                <a:latin typeface="Arial"/>
+              </a:rPr>
+              <a:t>Fallübergabe &amp; Fallarbeit</a:t>
+            </a:r>
+          </a:p>
+        </p:txBody>
+      </p:sp>
+      <p:sp>
+        <p:nvSpPr>
+          <p:cNvPr id="6" name="TextBox 5"/>
+          <p:cNvSpPr txBox="1"/>
+          <p:nvPr/>
+        </p:nvSpPr>
+        <p:spPr>
+          <a:xfrm>
+            <a:off x="685800" y="4480560"/>
+            <a:ext cx="8653881" cy="1280160"/>
+          </a:xfrm>
+          <a:prstGeom prst="rect">
+            <a:avLst/>
+          </a:prstGeom>
+          <a:noFill/>
+        </p:spPr>
+        <p:txBody>
+          <a:bodyPr wrap="square">
+            <a:spAutoFit/>
+          </a:bodyPr>
+          <a:lstStyle/>
+          <a:p>
+            <a:pPr algn="l"/>
+            <a:r>
+              <a:rPr sz="1600" b="0" i="0">
+                <a:solidFill>
+                  <a:srgbClr val="C8D2E6"/>
+                </a:solidFill>
+                <a:latin typeface="Arial"/>
+              </a:rPr>
+              <a:t>Ist die Auszahlung der Bau Musterregion GmbH freigabereif?</a:t>
+            </a:r>
+          </a:p>
+        </p:txBody>
+      </p:sp>
+      <p:sp>
+        <p:nvSpPr>
+          <p:cNvPr id="7" name="TextBox 6"/>
+          <p:cNvSpPr txBox="1"/>
+          <p:nvPr/>
+        </p:nvSpPr>
+        <p:spPr>
+          <a:xfrm>
+            <a:off x="685800" y="6355080"/>
+            <a:ext cx="10817352" cy="274320"/>
+          </a:xfrm>
+          <a:prstGeom prst="rect">
+            <a:avLst/>
+          </a:prstGeom>
+          <a:noFill/>
+        </p:spPr>
+        <p:txBody>
+          <a:bodyPr wrap="none">
+            <a:spAutoFit/>
+          </a:bodyPr>
+          <a:lstStyle/>
+          <a:p>
+            <a:pPr algn="l"/>
+            <a:r>
+              <a:rPr sz="700">
+                <a:solidFill>
+                  <a:srgbClr val="8CA0C3"/>
+                </a:solidFill>
+                <a:latin typeface="Consolas"/>
+              </a:rPr>
+              <a:t>FKB Campus  ·  VA02</a:t>
+            </a:r>
+          </a:p>
+        </p:txBody>
+      </p:sp>
+    </p:spTree>
+  </p:cSld>
+  <p:clrMapOvr>
+    <a:masterClrMapping/>
+  </p:clrMapOvr>
+</p:sld>
+</file>
+
+<file path=ppt/slides/slide12.xml><?xml version="1.0" encoding="utf-8"?>
+<p:sld xmlns:a="http://schemas.openxmlformats.org/drawingml/2006/main" xmlns:p="http://schemas.openxmlformats.org/presentationml/2006/main" xmlns:r="http://schemas.openxmlformats.org/officeDocument/2006/relationships">
+  <p:cSld>
+    <p:spTree>
+      <p:nvGrpSpPr>
+        <p:cNvPr id="1" name=""/>
+        <p:cNvGrpSpPr/>
+        <p:nvPr/>
+      </p:nvGrpSpPr>
+      <p:grpSpPr/>
+      <p:sp>
+        <p:nvSpPr>
+          <p:cNvPr id="2" name="Rectangle 1"/>
+          <p:cNvSpPr/>
+          <p:nvPr/>
+        </p:nvSpPr>
+        <p:spPr>
+          <a:xfrm>
+            <a:off x="0" y="0"/>
+            <a:ext cx="12188952" cy="6858000"/>
+          </a:xfrm>
+          <a:prstGeom prst="rect">
+            <a:avLst/>
+          </a:prstGeom>
+          <a:solidFill>
+            <a:srgbClr val="EDEDF3"/>
+          </a:solidFill>
+          <a:ln>
+            <a:noFill/>
+          </a:ln>
+        </p:spPr>
+        <p:style>
+          <a:lnRef idx="1">
+            <a:schemeClr val="accent1"/>
+          </a:lnRef>
+          <a:fillRef idx="3">
+            <a:schemeClr val="accent1"/>
+          </a:fillRef>
+          <a:effectRef idx="2">
+            <a:schemeClr val="accent1"/>
+          </a:effectRef>
+          <a:fontRef idx="minor">
+            <a:schemeClr val="lt1"/>
+          </a:fontRef>
+        </p:style>
+        <p:txBody>
+          <a:bodyPr rtlCol="0" anchor="ctr"/>
+          <a:lstStyle/>
+          <a:p>
+            <a:pPr algn="ctr"/>
+          </a:p>
+        </p:txBody>
+      </p:sp>
+      <p:sp>
+        <p:nvSpPr>
+          <p:cNvPr id="3" name="Rectangle 2"/>
+          <p:cNvSpPr/>
+          <p:nvPr/>
+        </p:nvSpPr>
+        <p:spPr>
+          <a:xfrm>
+            <a:off x="0" y="0"/>
+            <a:ext cx="12188952" cy="50292"/>
+          </a:xfrm>
+          <a:prstGeom prst="rect">
+            <a:avLst/>
+          </a:prstGeom>
+          <a:solidFill>
+            <a:srgbClr val="1F2C56"/>
+          </a:solidFill>
+          <a:ln>
+            <a:noFill/>
+          </a:ln>
+        </p:spPr>
+        <p:style>
+          <a:lnRef idx="1">
+            <a:schemeClr val="accent1"/>
+          </a:lnRef>
+          <a:fillRef idx="3">
+            <a:schemeClr val="accent1"/>
+          </a:fillRef>
+          <a:effectRef idx="2">
+            <a:schemeClr val="accent1"/>
+          </a:effectRef>
+          <a:fontRef idx="minor">
+            <a:schemeClr val="lt1"/>
+          </a:fontRef>
+        </p:style>
+        <p:txBody>
+          <a:bodyPr rtlCol="0" anchor="ctr"/>
+          <a:lstStyle/>
+          <a:p>
+            <a:pPr algn="ctr"/>
+          </a:p>
+        </p:txBody>
+      </p:sp>
+      <p:sp>
+        <p:nvSpPr>
+          <p:cNvPr id="4" name="TextBox 3"/>
+          <p:cNvSpPr txBox="1"/>
+          <p:nvPr/>
+        </p:nvSpPr>
+        <p:spPr>
+          <a:xfrm>
+            <a:off x="685800" y="109728"/>
+            <a:ext cx="10817352" cy="228600"/>
+          </a:xfrm>
+          <a:prstGeom prst="rect">
+            <a:avLst/>
+          </a:prstGeom>
+          <a:noFill/>
+        </p:spPr>
+        <p:txBody>
+          <a:bodyPr wrap="none">
+            <a:spAutoFit/>
+          </a:bodyPr>
+          <a:lstStyle/>
+          <a:p>
+            <a:pPr algn="l"/>
+            <a:r>
+              <a:rPr sz="750">
+                <a:solidFill>
+                  <a:srgbClr val="78808C"/>
+                </a:solidFill>
+                <a:latin typeface="Consolas"/>
+              </a:rPr>
+              <a:t>VA02  ·  INHALT</a:t>
+            </a:r>
+          </a:p>
+        </p:txBody>
+      </p:sp>
+      <p:sp>
+        <p:nvSpPr>
+          <p:cNvPr id="5" name="Rectangle 4"/>
+          <p:cNvSpPr/>
+          <p:nvPr/>
+        </p:nvSpPr>
+        <p:spPr>
+          <a:xfrm>
+            <a:off x="0" y="1234440"/>
+            <a:ext cx="12188952" cy="12700"/>
+          </a:xfrm>
+          <a:prstGeom prst="rect">
+            <a:avLst/>
+          </a:prstGeom>
+          <a:solidFill>
+            <a:srgbClr val="D8DFE4"/>
+          </a:solidFill>
+          <a:ln>
+            <a:noFill/>
+          </a:ln>
+        </p:spPr>
+        <p:style>
+          <a:lnRef idx="1">
+            <a:schemeClr val="accent1"/>
+          </a:lnRef>
+          <a:fillRef idx="3">
+            <a:schemeClr val="accent1"/>
+          </a:fillRef>
+          <a:effectRef idx="2">
+            <a:schemeClr val="accent1"/>
+          </a:effectRef>
+          <a:fontRef idx="minor">
+            <a:schemeClr val="lt1"/>
+          </a:fontRef>
+        </p:style>
+        <p:txBody>
+          <a:bodyPr rtlCol="0" anchor="ctr"/>
+          <a:lstStyle/>
+          <a:p>
+            <a:pPr algn="ctr"/>
+          </a:p>
+        </p:txBody>
+      </p:sp>
+      <p:sp>
+        <p:nvSpPr>
+          <p:cNvPr id="6" name="Rectangle 5"/>
+          <p:cNvSpPr/>
+          <p:nvPr/>
+        </p:nvSpPr>
+        <p:spPr>
+          <a:xfrm>
+            <a:off x="685800" y="502920"/>
+            <a:ext cx="36576" cy="658368"/>
+          </a:xfrm>
+          <a:prstGeom prst="rect">
+            <a:avLst/>
+          </a:prstGeom>
+          <a:solidFill>
+            <a:srgbClr val="D9C089"/>
+          </a:solidFill>
+          <a:ln>
+            <a:noFill/>
+          </a:ln>
+        </p:spPr>
+        <p:style>
+          <a:lnRef idx="1">
+            <a:schemeClr val="accent1"/>
+          </a:lnRef>
+          <a:fillRef idx="3">
+            <a:schemeClr val="accent1"/>
+          </a:fillRef>
+          <a:effectRef idx="2">
+            <a:schemeClr val="accent1"/>
+          </a:effectRef>
+          <a:fontRef idx="minor">
+            <a:schemeClr val="lt1"/>
+          </a:fontRef>
+        </p:style>
+        <p:txBody>
+          <a:bodyPr rtlCol="0" anchor="ctr"/>
+          <a:lstStyle/>
+          <a:p>
+            <a:pPr algn="ctr"/>
+          </a:p>
+        </p:txBody>
+      </p:sp>
+      <p:sp>
+        <p:nvSpPr>
+          <p:cNvPr id="7" name="TextBox 6"/>
+          <p:cNvSpPr txBox="1"/>
+          <p:nvPr/>
+        </p:nvSpPr>
+        <p:spPr>
+          <a:xfrm>
+            <a:off x="813816" y="502920"/>
+            <a:ext cx="10634472" cy="685800"/>
+          </a:xfrm>
+          <a:prstGeom prst="rect">
+            <a:avLst/>
+          </a:prstGeom>
+          <a:noFill/>
+        </p:spPr>
+        <p:txBody>
+          <a:bodyPr wrap="square">
+            <a:spAutoFit/>
+          </a:bodyPr>
+          <a:lstStyle/>
+          <a:p>
+            <a:pPr algn="l"/>
+            <a:r>
+              <a:rPr sz="2400" b="1" i="0">
+                <a:solidFill>
+                  <a:srgbClr val="1F2C56"/>
+                </a:solidFill>
+                <a:latin typeface="Arial"/>
+              </a:rPr>
+              <a:t>Praxisfall: Bau Musterregion GmbH</a:t>
+            </a:r>
+          </a:p>
+        </p:txBody>
+      </p:sp>
+      <p:sp>
+        <p:nvSpPr>
+          <p:cNvPr id="8" name="TextBox 7"/>
+          <p:cNvSpPr txBox="1"/>
+          <p:nvPr/>
+        </p:nvSpPr>
+        <p:spPr>
+          <a:xfrm>
+            <a:off x="685800" y="1417320"/>
+            <a:ext cx="10817352" cy="4892040"/>
+          </a:xfrm>
+          <a:prstGeom prst="rect">
+            <a:avLst/>
+          </a:prstGeom>
+          <a:noFill/>
+        </p:spPr>
+        <p:txBody>
+          <a:bodyPr wrap="square" anchor="ctr">
+            <a:spAutoFit/>
+          </a:bodyPr>
+          <a:lstStyle/>
+          <a:p>
+            <a:pPr>
+              <a:spcBef>
+                <a:spcPts val="1000"/>
+              </a:spcBef>
+              <a:spcAft>
+                <a:spcPts val="200"/>
+              </a:spcAft>
+            </a:pPr>
+            <a:r>
+              <a:rPr sz="800" b="1">
+                <a:solidFill>
+                  <a:srgbClr val="78808C"/>
+                </a:solidFill>
+                <a:latin typeface="Consolas"/>
+              </a:rPr>
+              <a:t>DER FALL</a:t>
+            </a:r>
+          </a:p>
+          <a:p>
+            <a:pPr marL="190500" indent="-190500">
+              <a:spcBef>
+                <a:spcPts val="400"/>
+              </a:spcBef>
+              <a:spcAft>
+                <a:spcPts val="200"/>
+              </a:spcAft>
+            </a:pPr>
+            <a:r>
+              <a:rPr sz="1300">
+                <a:solidFill>
+                  <a:srgbClr val="3D5466"/>
+                </a:solidFill>
+                <a:latin typeface="Arial"/>
+              </a:rPr>
+              <a:t>▸  Investitionskredit 900 TEUR, Hausbank VR-Bank Musterregion eG.</a:t>
+            </a:r>
+          </a:p>
+          <a:p>
+            <a:pPr marL="190500" indent="-190500">
+              <a:spcBef>
+                <a:spcPts val="400"/>
+              </a:spcBef>
+              <a:spcAft>
+                <a:spcPts val="200"/>
+              </a:spcAft>
+            </a:pPr>
+            <a:r>
+              <a:rPr sz="1300">
+                <a:solidFill>
+                  <a:srgbClr val="3D5466"/>
+                </a:solidFill>
+                <a:latin typeface="Arial"/>
+              </a:rPr>
+              <a:t>▸  Vereinbarte Sicherheiten: Grundschuld 900 TEUR auf das Betriebsgrundstück + Bürgschaft des Gesellschafter-GF über 100 TEUR.</a:t>
+            </a:r>
+          </a:p>
+          <a:p>
+            <a:pPr>
+              <a:spcBef>
+                <a:spcPts val="1000"/>
+              </a:spcBef>
+              <a:spcAft>
+                <a:spcPts val="200"/>
+              </a:spcAft>
+            </a:pPr>
+            <a:r>
+              <a:rPr sz="800" b="1">
+                <a:solidFill>
+                  <a:srgbClr val="78808C"/>
+                </a:solidFill>
+                <a:latin typeface="Consolas"/>
+              </a:rPr>
+              <a:t>IHRE AUFGABE</a:t>
+            </a:r>
+          </a:p>
+          <a:p>
+            <a:pPr marL="190500" indent="-190500">
+              <a:spcBef>
+                <a:spcPts val="400"/>
+              </a:spcBef>
+              <a:spcAft>
+                <a:spcPts val="200"/>
+              </a:spcAft>
+            </a:pPr>
+            <a:r>
+              <a:rPr sz="1300">
+                <a:solidFill>
+                  <a:srgbClr val="3D5466"/>
+                </a:solidFill>
+                <a:latin typeface="Arial"/>
+              </a:rPr>
+              <a:t>▸  Die Auszahlung soll erfolgen. Prüfen Sie, ob alle Voraussetzungen erfüllt sind.</a:t>
+            </a:r>
+          </a:p>
+        </p:txBody>
+      </p:sp>
+      <p:sp>
+        <p:nvSpPr>
+          <p:cNvPr id="9" name="Rectangle 8"/>
+          <p:cNvSpPr/>
+          <p:nvPr/>
+        </p:nvSpPr>
+        <p:spPr>
+          <a:xfrm>
+            <a:off x="0" y="6510528"/>
+            <a:ext cx="12188952" cy="347472"/>
+          </a:xfrm>
+          <a:prstGeom prst="rect">
+            <a:avLst/>
+          </a:prstGeom>
+          <a:solidFill>
+            <a:srgbClr val="0A1937"/>
+          </a:solidFill>
+          <a:ln>
+            <a:noFill/>
+          </a:ln>
+        </p:spPr>
+        <p:style>
+          <a:lnRef idx="1">
+            <a:schemeClr val="accent1"/>
+          </a:lnRef>
+          <a:fillRef idx="3">
+            <a:schemeClr val="accent1"/>
+          </a:fillRef>
+          <a:effectRef idx="2">
+            <a:schemeClr val="accent1"/>
+          </a:effectRef>
+          <a:fontRef idx="minor">
+            <a:schemeClr val="lt1"/>
+          </a:fontRef>
+        </p:style>
+        <p:txBody>
+          <a:bodyPr rtlCol="0" anchor="ctr"/>
+          <a:lstStyle/>
+          <a:p>
+            <a:pPr algn="ctr"/>
+          </a:p>
+        </p:txBody>
+      </p:sp>
+      <p:sp>
+        <p:nvSpPr>
+          <p:cNvPr id="10" name="TextBox 9"/>
+          <p:cNvSpPr txBox="1"/>
+          <p:nvPr/>
+        </p:nvSpPr>
+        <p:spPr>
+          <a:xfrm>
+            <a:off x="685800" y="6583680"/>
+            <a:ext cx="6490411" cy="256032"/>
+          </a:xfrm>
+          <a:prstGeom prst="rect">
+            <a:avLst/>
+          </a:prstGeom>
+          <a:noFill/>
+        </p:spPr>
+        <p:txBody>
+          <a:bodyPr wrap="none">
+            <a:spAutoFit/>
+          </a:bodyPr>
+          <a:lstStyle/>
+          <a:p>
+            <a:pPr algn="l"/>
+            <a:r>
+              <a:rPr sz="700">
+                <a:solidFill>
+                  <a:srgbClr val="A0B4D2"/>
+                </a:solidFill>
+                <a:latin typeface="Consolas"/>
+              </a:rPr>
+              <a:t>FKB Campus  ·  VA02</a:t>
+            </a:r>
+          </a:p>
+        </p:txBody>
+      </p:sp>
+    </p:spTree>
+  </p:cSld>
+  <p:clrMapOvr>
+    <a:masterClrMapping/>
+  </p:clrMapOvr>
+</p:sld>
+</file>
+
+<file path=ppt/slides/slide13.xml><?xml version="1.0" encoding="utf-8"?>
+<p:sld xmlns:a="http://schemas.openxmlformats.org/drawingml/2006/main" xmlns:p="http://schemas.openxmlformats.org/presentationml/2006/main" xmlns:r="http://schemas.openxmlformats.org/officeDocument/2006/relationships">
+  <p:cSld>
+    <p:spTree>
+      <p:nvGrpSpPr>
+        <p:cNvPr id="1" name=""/>
+        <p:cNvGrpSpPr/>
+        <p:nvPr/>
+      </p:nvGrpSpPr>
+      <p:grpSpPr/>
+      <p:sp>
+        <p:nvSpPr>
+          <p:cNvPr id="2" name="Rectangle 1"/>
+          <p:cNvSpPr/>
+          <p:nvPr/>
+        </p:nvSpPr>
+        <p:spPr>
+          <a:xfrm>
+            <a:off x="0" y="0"/>
+            <a:ext cx="12188952" cy="6858000"/>
+          </a:xfrm>
+          <a:prstGeom prst="rect">
+            <a:avLst/>
+          </a:prstGeom>
+          <a:solidFill>
+            <a:srgbClr val="EDEDF3"/>
+          </a:solidFill>
+          <a:ln>
+            <a:noFill/>
+          </a:ln>
+        </p:spPr>
+        <p:style>
+          <a:lnRef idx="1">
+            <a:schemeClr val="accent1"/>
+          </a:lnRef>
+          <a:fillRef idx="3">
+            <a:schemeClr val="accent1"/>
+          </a:fillRef>
+          <a:effectRef idx="2">
+            <a:schemeClr val="accent1"/>
+          </a:effectRef>
+          <a:fontRef idx="minor">
+            <a:schemeClr val="lt1"/>
+          </a:fontRef>
+        </p:style>
+        <p:txBody>
+          <a:bodyPr rtlCol="0" anchor="ctr"/>
+          <a:lstStyle/>
+          <a:p>
+            <a:pPr algn="ctr"/>
+          </a:p>
+        </p:txBody>
+      </p:sp>
+      <p:sp>
+        <p:nvSpPr>
+          <p:cNvPr id="3" name="Rectangle 2"/>
+          <p:cNvSpPr/>
+          <p:nvPr/>
+        </p:nvSpPr>
+        <p:spPr>
+          <a:xfrm>
+            <a:off x="0" y="0"/>
+            <a:ext cx="12188952" cy="50292"/>
+          </a:xfrm>
+          <a:prstGeom prst="rect">
+            <a:avLst/>
+          </a:prstGeom>
+          <a:solidFill>
+            <a:srgbClr val="1F2C56"/>
+          </a:solidFill>
+          <a:ln>
+            <a:noFill/>
+          </a:ln>
+        </p:spPr>
+        <p:style>
+          <a:lnRef idx="1">
+            <a:schemeClr val="accent1"/>
+          </a:lnRef>
+          <a:fillRef idx="3">
+            <a:schemeClr val="accent1"/>
+          </a:fillRef>
+          <a:effectRef idx="2">
+            <a:schemeClr val="accent1"/>
+          </a:effectRef>
+          <a:fontRef idx="minor">
+            <a:schemeClr val="lt1"/>
+          </a:fontRef>
+        </p:style>
+        <p:txBody>
+          <a:bodyPr rtlCol="0" anchor="ctr"/>
+          <a:lstStyle/>
+          <a:p>
+            <a:pPr algn="ctr"/>
+          </a:p>
+        </p:txBody>
+      </p:sp>
+      <p:sp>
+        <p:nvSpPr>
+          <p:cNvPr id="4" name="TextBox 3"/>
+          <p:cNvSpPr txBox="1"/>
+          <p:nvPr/>
+        </p:nvSpPr>
+        <p:spPr>
+          <a:xfrm>
+            <a:off x="685800" y="109728"/>
+            <a:ext cx="10817352" cy="228600"/>
+          </a:xfrm>
+          <a:prstGeom prst="rect">
+            <a:avLst/>
+          </a:prstGeom>
+          <a:noFill/>
+        </p:spPr>
+        <p:txBody>
+          <a:bodyPr wrap="none">
+            <a:spAutoFit/>
+          </a:bodyPr>
+          <a:lstStyle/>
+          <a:p>
+            <a:pPr algn="l"/>
+            <a:r>
+              <a:rPr sz="750">
+                <a:solidFill>
+                  <a:srgbClr val="78808C"/>
+                </a:solidFill>
+                <a:latin typeface="Consolas"/>
+              </a:rPr>
+              <a:t>VA02  ·  INHALT</a:t>
+            </a:r>
+          </a:p>
+        </p:txBody>
+      </p:sp>
+      <p:sp>
+        <p:nvSpPr>
+          <p:cNvPr id="5" name="Rectangle 4"/>
+          <p:cNvSpPr/>
+          <p:nvPr/>
+        </p:nvSpPr>
+        <p:spPr>
+          <a:xfrm>
+            <a:off x="0" y="1234440"/>
+            <a:ext cx="12188952" cy="12700"/>
+          </a:xfrm>
+          <a:prstGeom prst="rect">
+            <a:avLst/>
+          </a:prstGeom>
+          <a:solidFill>
+            <a:srgbClr val="D8DFE4"/>
+          </a:solidFill>
+          <a:ln>
+            <a:noFill/>
+          </a:ln>
+        </p:spPr>
+        <p:style>
+          <a:lnRef idx="1">
+            <a:schemeClr val="accent1"/>
+          </a:lnRef>
+          <a:fillRef idx="3">
+            <a:schemeClr val="accent1"/>
+          </a:fillRef>
+          <a:effectRef idx="2">
+            <a:schemeClr val="accent1"/>
+          </a:effectRef>
+          <a:fontRef idx="minor">
+            <a:schemeClr val="lt1"/>
+          </a:fontRef>
+        </p:style>
+        <p:txBody>
+          <a:bodyPr rtlCol="0" anchor="ctr"/>
+          <a:lstStyle/>
+          <a:p>
+            <a:pPr algn="ctr"/>
+          </a:p>
+        </p:txBody>
+      </p:sp>
+      <p:sp>
+        <p:nvSpPr>
+          <p:cNvPr id="6" name="Rectangle 5"/>
+          <p:cNvSpPr/>
+          <p:nvPr/>
+        </p:nvSpPr>
+        <p:spPr>
+          <a:xfrm>
+            <a:off x="685800" y="502920"/>
+            <a:ext cx="36576" cy="658368"/>
+          </a:xfrm>
+          <a:prstGeom prst="rect">
+            <a:avLst/>
+          </a:prstGeom>
+          <a:solidFill>
+            <a:srgbClr val="D9C089"/>
+          </a:solidFill>
+          <a:ln>
+            <a:noFill/>
+          </a:ln>
+        </p:spPr>
+        <p:style>
+          <a:lnRef idx="1">
+            <a:schemeClr val="accent1"/>
+          </a:lnRef>
+          <a:fillRef idx="3">
+            <a:schemeClr val="accent1"/>
+          </a:fillRef>
+          <a:effectRef idx="2">
+            <a:schemeClr val="accent1"/>
+          </a:effectRef>
+          <a:fontRef idx="minor">
+            <a:schemeClr val="lt1"/>
+          </a:fontRef>
+        </p:style>
+        <p:txBody>
+          <a:bodyPr rtlCol="0" anchor="ctr"/>
+          <a:lstStyle/>
+          <a:p>
+            <a:pPr algn="ctr"/>
+          </a:p>
+        </p:txBody>
+      </p:sp>
+      <p:sp>
+        <p:nvSpPr>
+          <p:cNvPr id="7" name="TextBox 6"/>
+          <p:cNvSpPr txBox="1"/>
+          <p:nvPr/>
+        </p:nvSpPr>
+        <p:spPr>
+          <a:xfrm>
+            <a:off x="813816" y="502920"/>
+            <a:ext cx="10634472" cy="685800"/>
+          </a:xfrm>
+          <a:prstGeom prst="rect">
+            <a:avLst/>
+          </a:prstGeom>
+          <a:noFill/>
+        </p:spPr>
+        <p:txBody>
+          <a:bodyPr wrap="square">
+            <a:spAutoFit/>
+          </a:bodyPr>
+          <a:lstStyle/>
+          <a:p>
+            <a:pPr algn="l"/>
+            <a:r>
+              <a:rPr sz="2400" b="1" i="0">
+                <a:solidFill>
+                  <a:srgbClr val="1F2C56"/>
+                </a:solidFill>
+                <a:latin typeface="Arial"/>
+              </a:rPr>
+              <a:t>Handlungsempfehlung: vom Mangel zur Eskalation</a:t>
+            </a:r>
+          </a:p>
+        </p:txBody>
+      </p:sp>
+      <p:sp>
+        <p:nvSpPr>
+          <p:cNvPr id="8" name="TextBox 7"/>
+          <p:cNvSpPr txBox="1"/>
+          <p:nvPr/>
+        </p:nvSpPr>
+        <p:spPr>
+          <a:xfrm>
+            <a:off x="685800" y="1417320"/>
+            <a:ext cx="10817352" cy="4892040"/>
+          </a:xfrm>
+          <a:prstGeom prst="rect">
+            <a:avLst/>
+          </a:prstGeom>
+          <a:noFill/>
+        </p:spPr>
+        <p:txBody>
+          <a:bodyPr wrap="square" anchor="ctr">
+            <a:spAutoFit/>
+          </a:bodyPr>
+          <a:lstStyle/>
+          <a:p>
+            <a:pPr marL="177800" indent="-177800">
+              <a:spcBef>
+                <a:spcPts val="600"/>
+              </a:spcBef>
+              <a:spcAft>
+                <a:spcPts val="200"/>
+              </a:spcAft>
+            </a:pPr>
+            <a:r>
+              <a:rPr sz="1200" i="1">
+                <a:solidFill>
+                  <a:srgbClr val="3D5466"/>
+                </a:solidFill>
+                <a:latin typeface="Arial"/>
+              </a:rPr>
+              <a:t>→  Wenn die Grundschuld nicht im vereinbarten Rang steht — dann Auszahlung stoppen und Rangklärung über die Marktfolge veranlassen.</a:t>
+            </a:r>
+          </a:p>
+          <a:p>
+            <a:pPr marL="177800" indent="-177800">
+              <a:spcBef>
+                <a:spcPts val="600"/>
+              </a:spcBef>
+              <a:spcAft>
+                <a:spcPts val="200"/>
+              </a:spcAft>
+            </a:pPr>
+            <a:r>
+              <a:rPr sz="1200" i="1">
+                <a:solidFill>
+                  <a:srgbClr val="3D5466"/>
+                </a:solidFill>
+                <a:latin typeface="Arial"/>
+              </a:rPr>
+              <a:t>→  Wenn ein Eigenmittelnachweis aus dem Kreditbeschluss fehlt — dann Nachweis beim Berater/Kunden anfordern und als offenen Punkt dokumentieren.</a:t>
+            </a:r>
+          </a:p>
+          <a:p>
+            <a:pPr marL="177800" indent="-177800">
+              <a:spcBef>
+                <a:spcPts val="600"/>
+              </a:spcBef>
+              <a:spcAft>
+                <a:spcPts val="200"/>
+              </a:spcAft>
+            </a:pPr>
+            <a:r>
+              <a:rPr sz="1200" i="1">
+                <a:solidFill>
+                  <a:srgbClr val="3D5466"/>
+                </a:solidFill>
+                <a:latin typeface="Arial"/>
+              </a:rPr>
+              <a:t>→  Wenn eine Bürgschaft ohne Schriftform vorliegt — dann als nichtig behandeln und formgerechte Neubestellung veranlassen (§ 766 BGB).</a:t>
+            </a:r>
+          </a:p>
+        </p:txBody>
+      </p:sp>
+      <p:sp>
+        <p:nvSpPr>
+          <p:cNvPr id="9" name="Rectangle 8"/>
+          <p:cNvSpPr/>
+          <p:nvPr/>
+        </p:nvSpPr>
+        <p:spPr>
+          <a:xfrm>
+            <a:off x="0" y="6510528"/>
+            <a:ext cx="12188952" cy="347472"/>
+          </a:xfrm>
+          <a:prstGeom prst="rect">
+            <a:avLst/>
+          </a:prstGeom>
+          <a:solidFill>
+            <a:srgbClr val="0A1937"/>
+          </a:solidFill>
+          <a:ln>
+            <a:noFill/>
+          </a:ln>
+        </p:spPr>
+        <p:style>
+          <a:lnRef idx="1">
+            <a:schemeClr val="accent1"/>
+          </a:lnRef>
+          <a:fillRef idx="3">
+            <a:schemeClr val="accent1"/>
+          </a:fillRef>
+          <a:effectRef idx="2">
+            <a:schemeClr val="accent1"/>
+          </a:effectRef>
+          <a:fontRef idx="minor">
+            <a:schemeClr val="lt1"/>
+          </a:fontRef>
+        </p:style>
+        <p:txBody>
+          <a:bodyPr rtlCol="0" anchor="ctr"/>
+          <a:lstStyle/>
+          <a:p>
+            <a:pPr algn="ctr"/>
+          </a:p>
+        </p:txBody>
+      </p:sp>
+      <p:sp>
+        <p:nvSpPr>
+          <p:cNvPr id="10" name="TextBox 9"/>
+          <p:cNvSpPr txBox="1"/>
+          <p:nvPr/>
+        </p:nvSpPr>
+        <p:spPr>
+          <a:xfrm>
+            <a:off x="685800" y="6583680"/>
+            <a:ext cx="6490411" cy="256032"/>
+          </a:xfrm>
+          <a:prstGeom prst="rect">
+            <a:avLst/>
+          </a:prstGeom>
+          <a:noFill/>
+        </p:spPr>
+        <p:txBody>
+          <a:bodyPr wrap="none">
+            <a:spAutoFit/>
+          </a:bodyPr>
+          <a:lstStyle/>
+          <a:p>
+            <a:pPr algn="l"/>
+            <a:r>
+              <a:rPr sz="700">
+                <a:solidFill>
+                  <a:srgbClr val="A0B4D2"/>
+                </a:solidFill>
+                <a:latin typeface="Consolas"/>
+              </a:rPr>
+              <a:t>FKB Campus  ·  VA02</a:t>
+            </a:r>
+          </a:p>
+        </p:txBody>
+      </p:sp>
+    </p:spTree>
+  </p:cSld>
+  <p:clrMapOvr>
+    <a:masterClrMapping/>
+  </p:clrMapOvr>
+</p:sld>
+</file>
+
+<file path=ppt/slides/slide14.xml><?xml version="1.0" encoding="utf-8"?>
+<p:sld xmlns:a="http://schemas.openxmlformats.org/drawingml/2006/main" xmlns:p="http://schemas.openxmlformats.org/presentationml/2006/main" xmlns:r="http://schemas.openxmlformats.org/officeDocument/2006/relationships">
+  <p:cSld>
+    <p:spTree>
+      <p:nvGrpSpPr>
+        <p:cNvPr id="1" name=""/>
+        <p:cNvGrpSpPr/>
+        <p:nvPr/>
+      </p:nvGrpSpPr>
+      <p:grpSpPr/>
+      <p:sp>
+        <p:nvSpPr>
+          <p:cNvPr id="2" name="Rectangle 1"/>
+          <p:cNvSpPr/>
+          <p:nvPr/>
+        </p:nvSpPr>
+        <p:spPr>
+          <a:xfrm>
+            <a:off x="0" y="0"/>
+            <a:ext cx="12188952" cy="6858000"/>
+          </a:xfrm>
+          <a:prstGeom prst="rect">
+            <a:avLst/>
+          </a:prstGeom>
+          <a:solidFill>
+            <a:srgbClr val="EDEDF3"/>
+          </a:solidFill>
+          <a:ln>
+            <a:noFill/>
+          </a:ln>
+        </p:spPr>
+        <p:style>
+          <a:lnRef idx="1">
+            <a:schemeClr val="accent1"/>
+          </a:lnRef>
+          <a:fillRef idx="3">
+            <a:schemeClr val="accent1"/>
+          </a:fillRef>
+          <a:effectRef idx="2">
+            <a:schemeClr val="accent1"/>
+          </a:effectRef>
+          <a:fontRef idx="minor">
+            <a:schemeClr val="lt1"/>
+          </a:fontRef>
+        </p:style>
+        <p:txBody>
+          <a:bodyPr rtlCol="0" anchor="ctr"/>
+          <a:lstStyle/>
+          <a:p>
+            <a:pPr algn="ctr"/>
+          </a:p>
+        </p:txBody>
+      </p:sp>
+      <p:sp>
+        <p:nvSpPr>
+          <p:cNvPr id="3" name="Rectangle 2"/>
+          <p:cNvSpPr/>
+          <p:nvPr/>
+        </p:nvSpPr>
+        <p:spPr>
+          <a:xfrm>
+            <a:off x="0" y="0"/>
+            <a:ext cx="12188952" cy="50292"/>
+          </a:xfrm>
+          <a:prstGeom prst="rect">
+            <a:avLst/>
+          </a:prstGeom>
+          <a:solidFill>
+            <a:srgbClr val="1F2C56"/>
+          </a:solidFill>
+          <a:ln>
+            <a:noFill/>
+          </a:ln>
+        </p:spPr>
+        <p:style>
+          <a:lnRef idx="1">
+            <a:schemeClr val="accent1"/>
+          </a:lnRef>
+          <a:fillRef idx="3">
+            <a:schemeClr val="accent1"/>
+          </a:fillRef>
+          <a:effectRef idx="2">
+            <a:schemeClr val="accent1"/>
+          </a:effectRef>
+          <a:fontRef idx="minor">
+            <a:schemeClr val="lt1"/>
+          </a:fontRef>
+        </p:style>
+        <p:txBody>
+          <a:bodyPr rtlCol="0" anchor="ctr"/>
+          <a:lstStyle/>
+          <a:p>
+            <a:pPr algn="ctr"/>
+          </a:p>
+        </p:txBody>
+      </p:sp>
+      <p:sp>
+        <p:nvSpPr>
+          <p:cNvPr id="4" name="TextBox 3"/>
+          <p:cNvSpPr txBox="1"/>
+          <p:nvPr/>
+        </p:nvSpPr>
+        <p:spPr>
+          <a:xfrm>
+            <a:off x="685800" y="109728"/>
+            <a:ext cx="10817352" cy="228600"/>
+          </a:xfrm>
+          <a:prstGeom prst="rect">
+            <a:avLst/>
+          </a:prstGeom>
+          <a:noFill/>
+        </p:spPr>
+        <p:txBody>
+          <a:bodyPr wrap="none">
+            <a:spAutoFit/>
+          </a:bodyPr>
+          <a:lstStyle/>
+          <a:p>
+            <a:pPr algn="l"/>
+            <a:r>
+              <a:rPr sz="750">
+                <a:solidFill>
+                  <a:srgbClr val="78808C"/>
+                </a:solidFill>
+                <a:latin typeface="Consolas"/>
+              </a:rPr>
+              <a:t>VA02  ·  ARBEITSBLATT</a:t>
+            </a:r>
+          </a:p>
+        </p:txBody>
+      </p:sp>
+      <p:sp>
+        <p:nvSpPr>
+          <p:cNvPr id="5" name="Rectangle 4"/>
+          <p:cNvSpPr/>
+          <p:nvPr/>
+        </p:nvSpPr>
+        <p:spPr>
+          <a:xfrm>
+            <a:off x="0" y="1234440"/>
+            <a:ext cx="12188952" cy="12700"/>
+          </a:xfrm>
+          <a:prstGeom prst="rect">
+            <a:avLst/>
+          </a:prstGeom>
+          <a:solidFill>
+            <a:srgbClr val="D8DFE4"/>
+          </a:solidFill>
+          <a:ln>
+            <a:noFill/>
+          </a:ln>
+        </p:spPr>
+        <p:style>
+          <a:lnRef idx="1">
+            <a:schemeClr val="accent1"/>
+          </a:lnRef>
+          <a:fillRef idx="3">
+            <a:schemeClr val="accent1"/>
+          </a:fillRef>
+          <a:effectRef idx="2">
+            <a:schemeClr val="accent1"/>
+          </a:effectRef>
+          <a:fontRef idx="minor">
+            <a:schemeClr val="lt1"/>
+          </a:fontRef>
+        </p:style>
+        <p:txBody>
+          <a:bodyPr rtlCol="0" anchor="ctr"/>
+          <a:lstStyle/>
+          <a:p>
+            <a:pPr algn="ctr"/>
+          </a:p>
+        </p:txBody>
+      </p:sp>
+      <p:sp>
+        <p:nvSpPr>
+          <p:cNvPr id="6" name="Rectangle 5"/>
+          <p:cNvSpPr/>
+          <p:nvPr/>
+        </p:nvSpPr>
+        <p:spPr>
+          <a:xfrm>
+            <a:off x="685800" y="502920"/>
+            <a:ext cx="36576" cy="658368"/>
+          </a:xfrm>
+          <a:prstGeom prst="rect">
+            <a:avLst/>
+          </a:prstGeom>
+          <a:solidFill>
+            <a:srgbClr val="D9C089"/>
+          </a:solidFill>
+          <a:ln>
+            <a:noFill/>
+          </a:ln>
+        </p:spPr>
+        <p:style>
+          <a:lnRef idx="1">
+            <a:schemeClr val="accent1"/>
+          </a:lnRef>
+          <a:fillRef idx="3">
+            <a:schemeClr val="accent1"/>
+          </a:fillRef>
+          <a:effectRef idx="2">
+            <a:schemeClr val="accent1"/>
+          </a:effectRef>
+          <a:fontRef idx="minor">
+            <a:schemeClr val="lt1"/>
+          </a:fontRef>
+        </p:style>
+        <p:txBody>
+          <a:bodyPr rtlCol="0" anchor="ctr"/>
+          <a:lstStyle/>
+          <a:p>
+            <a:pPr algn="ctr"/>
+          </a:p>
+        </p:txBody>
+      </p:sp>
+      <p:sp>
+        <p:nvSpPr>
+          <p:cNvPr id="7" name="TextBox 6"/>
+          <p:cNvSpPr txBox="1"/>
+          <p:nvPr/>
+        </p:nvSpPr>
+        <p:spPr>
+          <a:xfrm>
+            <a:off x="813816" y="502920"/>
+            <a:ext cx="10634472" cy="685800"/>
+          </a:xfrm>
+          <a:prstGeom prst="rect">
+            <a:avLst/>
+          </a:prstGeom>
+          <a:noFill/>
+        </p:spPr>
+        <p:txBody>
+          <a:bodyPr wrap="square">
+            <a:spAutoFit/>
+          </a:bodyPr>
+          <a:lstStyle/>
+          <a:p>
+            <a:pPr algn="l"/>
+            <a:r>
+              <a:rPr sz="2400" b="1" i="0">
+                <a:solidFill>
+                  <a:srgbClr val="1F2C56"/>
+                </a:solidFill>
+                <a:latin typeface="Arial"/>
+              </a:rPr>
+              <a:t>Praxisfall bearbeiten: Auszahlung prüfen</a:t>
+            </a:r>
+          </a:p>
+        </p:txBody>
+      </p:sp>
+      <p:sp>
+        <p:nvSpPr>
+          <p:cNvPr id="8" name="TextBox 7"/>
+          <p:cNvSpPr txBox="1"/>
+          <p:nvPr/>
+        </p:nvSpPr>
+        <p:spPr>
+          <a:xfrm>
+            <a:off x="685800" y="1554480"/>
+            <a:ext cx="10817352" cy="3840480"/>
+          </a:xfrm>
+          <a:prstGeom prst="rect">
+            <a:avLst/>
+          </a:prstGeom>
+          <a:noFill/>
+        </p:spPr>
+        <p:txBody>
+          <a:bodyPr wrap="square">
+            <a:spAutoFit/>
+          </a:bodyPr>
+          <a:lstStyle/>
+          <a:p>
+            <a:pPr marL="190500" indent="-190500">
+              <a:spcBef>
+                <a:spcPts val="400"/>
+              </a:spcBef>
+              <a:spcAft>
+                <a:spcPts val="200"/>
+              </a:spcAft>
+            </a:pPr>
+            <a:r>
+              <a:rPr sz="1400">
+                <a:solidFill>
+                  <a:srgbClr val="3D5466"/>
+                </a:solidFill>
+                <a:latin typeface="Arial"/>
+              </a:rPr>
+              <a:t>▸  Ordnen Sie die vereinbarten Sicherheiten ihren Typen und Unterlagen zu (AB-1).</a:t>
+            </a:r>
+          </a:p>
+          <a:p>
+            <a:pPr marL="190500" indent="-190500">
+              <a:spcBef>
+                <a:spcPts val="400"/>
+              </a:spcBef>
+              <a:spcAft>
+                <a:spcPts val="200"/>
+              </a:spcAft>
+            </a:pPr>
+            <a:r>
+              <a:rPr sz="1400">
+                <a:solidFill>
+                  <a:srgbClr val="3D5466"/>
+                </a:solidFill>
+                <a:latin typeface="Arial"/>
+              </a:rPr>
+              <a:t>▸  Prüfen Sie die sechs Auszahlungsvoraussetzungen anhand der Falldaten (AB-2).</a:t>
+            </a:r>
+          </a:p>
+          <a:p>
+            <a:pPr marL="190500" indent="-190500">
+              <a:spcBef>
+                <a:spcPts val="400"/>
+              </a:spcBef>
+              <a:spcAft>
+                <a:spcPts val="200"/>
+              </a:spcAft>
+            </a:pPr>
+            <a:r>
+              <a:rPr sz="1400">
+                <a:solidFill>
+                  <a:srgbClr val="3D5466"/>
+                </a:solidFill>
+                <a:latin typeface="Arial"/>
+              </a:rPr>
+              <a:t>▸  Benennen Sie die Mängel, die die Auszahlung blockieren (AB-3).</a:t>
+            </a:r>
+          </a:p>
+          <a:p>
+            <a:pPr marL="190500" indent="-190500">
+              <a:spcBef>
+                <a:spcPts val="400"/>
+              </a:spcBef>
+              <a:spcAft>
+                <a:spcPts val="200"/>
+              </a:spcAft>
+            </a:pPr>
+            <a:r>
+              <a:rPr sz="1400">
+                <a:solidFill>
+                  <a:srgbClr val="3D5466"/>
+                </a:solidFill>
+                <a:latin typeface="Arial"/>
+              </a:rPr>
+              <a:t>▸  Strukturieren Sie die Eskalation: Wer erhält was? (AB-4) – nutzen Sie die Prüfkarte AB-5.</a:t>
+            </a:r>
+          </a:p>
+        </p:txBody>
+      </p:sp>
+      <p:sp>
+        <p:nvSpPr>
+          <p:cNvPr id="9" name="Rectangle 8"/>
+          <p:cNvSpPr/>
+          <p:nvPr/>
+        </p:nvSpPr>
+        <p:spPr>
+          <a:xfrm>
+            <a:off x="685800" y="5486400"/>
+            <a:ext cx="10817352" cy="640080"/>
+          </a:xfrm>
+          <a:prstGeom prst="rect">
+            <a:avLst/>
+          </a:prstGeom>
+          <a:solidFill>
+            <a:srgbClr val="1F2C56"/>
+          </a:solidFill>
+          <a:ln>
+            <a:noFill/>
+          </a:ln>
+        </p:spPr>
+        <p:style>
+          <a:lnRef idx="1">
+            <a:schemeClr val="accent1"/>
+          </a:lnRef>
+          <a:fillRef idx="3">
+            <a:schemeClr val="accent1"/>
+          </a:fillRef>
+          <a:effectRef idx="2">
+            <a:schemeClr val="accent1"/>
+          </a:effectRef>
+          <a:fontRef idx="minor">
+            <a:schemeClr val="lt1"/>
+          </a:fontRef>
+        </p:style>
+        <p:txBody>
+          <a:bodyPr rtlCol="0" anchor="ctr"/>
+          <a:lstStyle/>
+          <a:p>
+            <a:pPr algn="ctr"/>
+          </a:p>
+        </p:txBody>
+      </p:sp>
+      <p:sp>
+        <p:nvSpPr>
+          <p:cNvPr id="10" name="TextBox 9"/>
+          <p:cNvSpPr txBox="1"/>
+          <p:nvPr/>
+        </p:nvSpPr>
+        <p:spPr>
+          <a:xfrm>
+            <a:off x="868680" y="5596128"/>
+            <a:ext cx="10451592" cy="457200"/>
+          </a:xfrm>
+          <a:prstGeom prst="rect">
+            <a:avLst/>
+          </a:prstGeom>
+          <a:noFill/>
+        </p:spPr>
+        <p:txBody>
+          <a:bodyPr wrap="square">
+            <a:spAutoFit/>
+          </a:bodyPr>
+          <a:lstStyle/>
+          <a:p>
+            <a:pPr algn="l"/>
+            <a:r>
+              <a:rPr sz="1300" b="1" i="0">
+                <a:solidFill>
+                  <a:srgbClr val="FFFFFF"/>
+                </a:solidFill>
+                <a:latin typeface="Arial"/>
+              </a:rPr>
+              <a:t>→  Bearbeitung im Teilnehmer-Workbook (Arbeitsblatt mit Ausfüllfeldern)</a:t>
+            </a:r>
+          </a:p>
+        </p:txBody>
+      </p:sp>
+      <p:sp>
+        <p:nvSpPr>
+          <p:cNvPr id="11" name="Rectangle 10"/>
+          <p:cNvSpPr/>
+          <p:nvPr/>
+        </p:nvSpPr>
+        <p:spPr>
+          <a:xfrm>
+            <a:off x="0" y="6510528"/>
+            <a:ext cx="12188952" cy="347472"/>
+          </a:xfrm>
+          <a:prstGeom prst="rect">
+            <a:avLst/>
+          </a:prstGeom>
+          <a:solidFill>
+            <a:srgbClr val="0A1937"/>
+          </a:solidFill>
+          <a:ln>
+            <a:noFill/>
+          </a:ln>
+        </p:spPr>
+        <p:style>
+          <a:lnRef idx="1">
+            <a:schemeClr val="accent1"/>
+          </a:lnRef>
+          <a:fillRef idx="3">
+            <a:schemeClr val="accent1"/>
+          </a:fillRef>
+          <a:effectRef idx="2">
+            <a:schemeClr val="accent1"/>
+          </a:effectRef>
+          <a:fontRef idx="minor">
+            <a:schemeClr val="lt1"/>
+          </a:fontRef>
+        </p:style>
+        <p:txBody>
+          <a:bodyPr rtlCol="0" anchor="ctr"/>
+          <a:lstStyle/>
+          <a:p>
+            <a:pPr algn="ctr"/>
+          </a:p>
+        </p:txBody>
+      </p:sp>
+      <p:sp>
+        <p:nvSpPr>
+          <p:cNvPr id="12" name="TextBox 11"/>
+          <p:cNvSpPr txBox="1"/>
+          <p:nvPr/>
+        </p:nvSpPr>
+        <p:spPr>
+          <a:xfrm>
+            <a:off x="685800" y="6583680"/>
+            <a:ext cx="6490411" cy="256032"/>
+          </a:xfrm>
+          <a:prstGeom prst="rect">
+            <a:avLst/>
+          </a:prstGeom>
+          <a:noFill/>
+        </p:spPr>
+        <p:txBody>
+          <a:bodyPr wrap="none">
+            <a:spAutoFit/>
+          </a:bodyPr>
+          <a:lstStyle/>
+          <a:p>
+            <a:pPr algn="l"/>
+            <a:r>
+              <a:rPr sz="700">
+                <a:solidFill>
+                  <a:srgbClr val="A0B4D2"/>
+                </a:solidFill>
+                <a:latin typeface="Consolas"/>
+              </a:rPr>
+              <a:t>FKB Campus  ·  VA02</a:t>
+            </a:r>
+          </a:p>
+        </p:txBody>
+      </p:sp>
+    </p:spTree>
+  </p:cSld>
+  <p:clrMapOvr>
+    <a:masterClrMapping/>
+  </p:clrMapOvr>
+</p:sld>
+</file>
+
+<file path=ppt/slides/slide15.xml><?xml version="1.0" encoding="utf-8"?>
+<p:sld xmlns:a="http://schemas.openxmlformats.org/drawingml/2006/main" xmlns:p="http://schemas.openxmlformats.org/presentationml/2006/main" xmlns:r="http://schemas.openxmlformats.org/officeDocument/2006/relationships">
+  <p:cSld>
+    <p:spTree>
+      <p:nvGrpSpPr>
+        <p:cNvPr id="1" name=""/>
+        <p:cNvGrpSpPr/>
+        <p:nvPr/>
+      </p:nvGrpSpPr>
+      <p:grpSpPr/>
+      <p:sp>
+        <p:nvSpPr>
+          <p:cNvPr id="2" name="Rectangle 1"/>
+          <p:cNvSpPr/>
+          <p:nvPr/>
+        </p:nvSpPr>
+        <p:spPr>
+          <a:xfrm>
+            <a:off x="0" y="0"/>
+            <a:ext cx="12188952" cy="6858000"/>
+          </a:xfrm>
+          <a:prstGeom prst="rect">
+            <a:avLst/>
+          </a:prstGeom>
+          <a:solidFill>
+            <a:srgbClr val="EDEDF3"/>
+          </a:solidFill>
+          <a:ln>
+            <a:noFill/>
+          </a:ln>
+        </p:spPr>
+        <p:style>
+          <a:lnRef idx="1">
+            <a:schemeClr val="accent1"/>
+          </a:lnRef>
+          <a:fillRef idx="3">
+            <a:schemeClr val="accent1"/>
+          </a:fillRef>
+          <a:effectRef idx="2">
+            <a:schemeClr val="accent1"/>
+          </a:effectRef>
+          <a:fontRef idx="minor">
+            <a:schemeClr val="lt1"/>
+          </a:fontRef>
+        </p:style>
+        <p:txBody>
+          <a:bodyPr rtlCol="0" anchor="ctr"/>
+          <a:lstStyle/>
+          <a:p>
+            <a:pPr algn="ctr"/>
+          </a:p>
+        </p:txBody>
+      </p:sp>
+      <p:sp>
+        <p:nvSpPr>
+          <p:cNvPr id="3" name="Rectangle 2"/>
+          <p:cNvSpPr/>
+          <p:nvPr/>
+        </p:nvSpPr>
+        <p:spPr>
+          <a:xfrm>
+            <a:off x="0" y="0"/>
+            <a:ext cx="12188952" cy="50292"/>
+          </a:xfrm>
+          <a:prstGeom prst="rect">
+            <a:avLst/>
+          </a:prstGeom>
+          <a:solidFill>
+            <a:srgbClr val="1F2C56"/>
+          </a:solidFill>
+          <a:ln>
+            <a:noFill/>
+          </a:ln>
+        </p:spPr>
+        <p:style>
+          <a:lnRef idx="1">
+            <a:schemeClr val="accent1"/>
+          </a:lnRef>
+          <a:fillRef idx="3">
+            <a:schemeClr val="accent1"/>
+          </a:fillRef>
+          <a:effectRef idx="2">
+            <a:schemeClr val="accent1"/>
+          </a:effectRef>
+          <a:fontRef idx="minor">
+            <a:schemeClr val="lt1"/>
+          </a:fontRef>
+        </p:style>
+        <p:txBody>
+          <a:bodyPr rtlCol="0" anchor="ctr"/>
+          <a:lstStyle/>
+          <a:p>
+            <a:pPr algn="ctr"/>
+          </a:p>
+        </p:txBody>
+      </p:sp>
+      <p:sp>
+        <p:nvSpPr>
+          <p:cNvPr id="4" name="TextBox 3"/>
+          <p:cNvSpPr txBox="1"/>
+          <p:nvPr/>
+        </p:nvSpPr>
+        <p:spPr>
+          <a:xfrm>
+            <a:off x="685800" y="109728"/>
+            <a:ext cx="10817352" cy="228600"/>
+          </a:xfrm>
+          <a:prstGeom prst="rect">
+            <a:avLst/>
+          </a:prstGeom>
+          <a:noFill/>
+        </p:spPr>
+        <p:txBody>
+          <a:bodyPr wrap="none">
+            <a:spAutoFit/>
+          </a:bodyPr>
+          <a:lstStyle/>
+          <a:p>
+            <a:pPr algn="l"/>
+            <a:r>
+              <a:rPr sz="750">
+                <a:solidFill>
+                  <a:srgbClr val="78808C"/>
+                </a:solidFill>
+                <a:latin typeface="Consolas"/>
+              </a:rPr>
+              <a:t>VA02  ·  INHALT</a:t>
+            </a:r>
+          </a:p>
+        </p:txBody>
+      </p:sp>
+      <p:sp>
+        <p:nvSpPr>
+          <p:cNvPr id="5" name="Rectangle 4"/>
+          <p:cNvSpPr/>
+          <p:nvPr/>
+        </p:nvSpPr>
+        <p:spPr>
+          <a:xfrm>
+            <a:off x="0" y="1234440"/>
+            <a:ext cx="12188952" cy="12700"/>
+          </a:xfrm>
+          <a:prstGeom prst="rect">
+            <a:avLst/>
+          </a:prstGeom>
+          <a:solidFill>
+            <a:srgbClr val="D8DFE4"/>
+          </a:solidFill>
+          <a:ln>
+            <a:noFill/>
+          </a:ln>
+        </p:spPr>
+        <p:style>
+          <a:lnRef idx="1">
+            <a:schemeClr val="accent1"/>
+          </a:lnRef>
+          <a:fillRef idx="3">
+            <a:schemeClr val="accent1"/>
+          </a:fillRef>
+          <a:effectRef idx="2">
+            <a:schemeClr val="accent1"/>
+          </a:effectRef>
+          <a:fontRef idx="minor">
+            <a:schemeClr val="lt1"/>
+          </a:fontRef>
+        </p:style>
+        <p:txBody>
+          <a:bodyPr rtlCol="0" anchor="ctr"/>
+          <a:lstStyle/>
+          <a:p>
+            <a:pPr algn="ctr"/>
+          </a:p>
+        </p:txBody>
+      </p:sp>
+      <p:sp>
+        <p:nvSpPr>
+          <p:cNvPr id="6" name="Rectangle 5"/>
+          <p:cNvSpPr/>
+          <p:nvPr/>
+        </p:nvSpPr>
+        <p:spPr>
+          <a:xfrm>
+            <a:off x="685800" y="502920"/>
+            <a:ext cx="36576" cy="658368"/>
+          </a:xfrm>
+          <a:prstGeom prst="rect">
+            <a:avLst/>
+          </a:prstGeom>
+          <a:solidFill>
+            <a:srgbClr val="D9C089"/>
+          </a:solidFill>
+          <a:ln>
+            <a:noFill/>
+          </a:ln>
+        </p:spPr>
+        <p:style>
+          <a:lnRef idx="1">
+            <a:schemeClr val="accent1"/>
+          </a:lnRef>
+          <a:fillRef idx="3">
+            <a:schemeClr val="accent1"/>
+          </a:fillRef>
+          <a:effectRef idx="2">
+            <a:schemeClr val="accent1"/>
+          </a:effectRef>
+          <a:fontRef idx="minor">
+            <a:schemeClr val="lt1"/>
+          </a:fontRef>
+        </p:style>
+        <p:txBody>
+          <a:bodyPr rtlCol="0" anchor="ctr"/>
+          <a:lstStyle/>
+          <a:p>
+            <a:pPr algn="ctr"/>
+          </a:p>
+        </p:txBody>
+      </p:sp>
+      <p:sp>
+        <p:nvSpPr>
+          <p:cNvPr id="7" name="TextBox 6"/>
+          <p:cNvSpPr txBox="1"/>
+          <p:nvPr/>
+        </p:nvSpPr>
+        <p:spPr>
+          <a:xfrm>
+            <a:off x="813816" y="502920"/>
+            <a:ext cx="10634472" cy="685800"/>
+          </a:xfrm>
+          <a:prstGeom prst="rect">
+            <a:avLst/>
+          </a:prstGeom>
+          <a:noFill/>
+        </p:spPr>
+        <p:txBody>
+          <a:bodyPr wrap="square">
+            <a:spAutoFit/>
+          </a:bodyPr>
+          <a:lstStyle/>
+          <a:p>
+            <a:pPr algn="l"/>
+            <a:r>
+              <a:rPr sz="2400" b="1" i="0">
+                <a:solidFill>
+                  <a:srgbClr val="1F2C56"/>
+                </a:solidFill>
+                <a:latin typeface="Arial"/>
+              </a:rPr>
+              <a:t>Prinzip dieses Moduls</a:t>
+            </a:r>
+          </a:p>
+        </p:txBody>
+      </p:sp>
+      <p:sp>
+        <p:nvSpPr>
+          <p:cNvPr id="8" name="TextBox 7"/>
+          <p:cNvSpPr txBox="1"/>
+          <p:nvPr/>
+        </p:nvSpPr>
+        <p:spPr>
+          <a:xfrm>
+            <a:off x="685800" y="1417320"/>
+            <a:ext cx="10817352" cy="4892040"/>
+          </a:xfrm>
+          <a:prstGeom prst="rect">
+            <a:avLst/>
+          </a:prstGeom>
+          <a:noFill/>
+        </p:spPr>
+        <p:txBody>
+          <a:bodyPr wrap="square" anchor="ctr">
+            <a:spAutoFit/>
+          </a:bodyPr>
+          <a:lstStyle/>
+          <a:p>
+            <a:pPr marL="177800" indent="-177800">
+              <a:spcBef>
+                <a:spcPts val="600"/>
+              </a:spcBef>
+              <a:spcAft>
+                <a:spcPts val="200"/>
+              </a:spcAft>
+            </a:pPr>
+            <a:r>
+              <a:rPr sz="1200" i="1">
+                <a:solidFill>
+                  <a:srgbClr val="3D5466"/>
+                </a:solidFill>
+                <a:latin typeface="Arial"/>
+              </a:rPr>
+              <a:t>→  Erst die Voraussetzungen, dann die Auszahlung.</a:t>
+            </a:r>
+          </a:p>
+          <a:p>
+            <a:pPr marL="190500" indent="-190500">
+              <a:spcBef>
+                <a:spcPts val="400"/>
+              </a:spcBef>
+              <a:spcAft>
+                <a:spcPts val="200"/>
+              </a:spcAft>
+            </a:pPr>
+            <a:r>
+              <a:rPr sz="1300">
+                <a:solidFill>
+                  <a:srgbClr val="3D5466"/>
+                </a:solidFill>
+                <a:latin typeface="Arial"/>
+              </a:rPr>
+              <a:t>▸  Eine formal korrekt bestellte, werthaltige Sicherheit ist Bedingung, kein Nachtrag – Genauigkeit geht vor Tempo.</a:t>
+            </a:r>
+          </a:p>
+        </p:txBody>
+      </p:sp>
+      <p:sp>
+        <p:nvSpPr>
+          <p:cNvPr id="9" name="Rectangle 8"/>
+          <p:cNvSpPr/>
+          <p:nvPr/>
+        </p:nvSpPr>
+        <p:spPr>
+          <a:xfrm>
+            <a:off x="0" y="6510528"/>
+            <a:ext cx="12188952" cy="347472"/>
+          </a:xfrm>
+          <a:prstGeom prst="rect">
+            <a:avLst/>
+          </a:prstGeom>
+          <a:solidFill>
+            <a:srgbClr val="0A1937"/>
+          </a:solidFill>
+          <a:ln>
+            <a:noFill/>
+          </a:ln>
+        </p:spPr>
+        <p:style>
+          <a:lnRef idx="1">
+            <a:schemeClr val="accent1"/>
+          </a:lnRef>
+          <a:fillRef idx="3">
+            <a:schemeClr val="accent1"/>
+          </a:fillRef>
+          <a:effectRef idx="2">
+            <a:schemeClr val="accent1"/>
+          </a:effectRef>
+          <a:fontRef idx="minor">
+            <a:schemeClr val="lt1"/>
+          </a:fontRef>
+        </p:style>
+        <p:txBody>
+          <a:bodyPr rtlCol="0" anchor="ctr"/>
+          <a:lstStyle/>
+          <a:p>
+            <a:pPr algn="ctr"/>
+          </a:p>
+        </p:txBody>
+      </p:sp>
+      <p:sp>
+        <p:nvSpPr>
+          <p:cNvPr id="10" name="TextBox 9"/>
+          <p:cNvSpPr txBox="1"/>
+          <p:nvPr/>
+        </p:nvSpPr>
+        <p:spPr>
+          <a:xfrm>
+            <a:off x="685800" y="6583680"/>
+            <a:ext cx="6490411" cy="256032"/>
+          </a:xfrm>
+          <a:prstGeom prst="rect">
+            <a:avLst/>
+          </a:prstGeom>
+          <a:noFill/>
+        </p:spPr>
+        <p:txBody>
+          <a:bodyPr wrap="none">
+            <a:spAutoFit/>
+          </a:bodyPr>
+          <a:lstStyle/>
+          <a:p>
+            <a:pPr algn="l"/>
+            <a:r>
+              <a:rPr sz="700">
+                <a:solidFill>
+                  <a:srgbClr val="A0B4D2"/>
+                </a:solidFill>
+                <a:latin typeface="Consolas"/>
+              </a:rPr>
+              <a:t>FKB Campus  ·  VA02</a:t>
+            </a:r>
+          </a:p>
+        </p:txBody>
+      </p:sp>
+    </p:spTree>
+  </p:cSld>
+  <p:clrMapOvr>
+    <a:masterClrMapping/>
+  </p:clrMapOvr>
+</p:sld>
+</file>
+
+<file path=ppt/slides/slide16.xml><?xml version="1.0" encoding="utf-8"?>
+<p:sld xmlns:a="http://schemas.openxmlformats.org/drawingml/2006/main" xmlns:p="http://schemas.openxmlformats.org/presentationml/2006/main" xmlns:r="http://schemas.openxmlformats.org/officeDocument/2006/relationships">
+  <p:cSld>
+    <p:spTree>
+      <p:nvGrpSpPr>
+        <p:cNvPr id="1" name=""/>
+        <p:cNvGrpSpPr/>
+        <p:nvPr/>
+      </p:nvGrpSpPr>
+      <p:grpSpPr/>
+      <p:sp>
+        <p:nvSpPr>
+          <p:cNvPr id="2" name="Rectangle 1"/>
+          <p:cNvSpPr/>
+          <p:nvPr/>
+        </p:nvSpPr>
+        <p:spPr>
+          <a:xfrm>
+            <a:off x="0" y="0"/>
+            <a:ext cx="12188952" cy="6858000"/>
+          </a:xfrm>
+          <a:prstGeom prst="rect">
+            <a:avLst/>
+          </a:prstGeom>
+          <a:solidFill>
+            <a:srgbClr val="EDEDF3"/>
+          </a:solidFill>
+          <a:ln>
+            <a:noFill/>
+          </a:ln>
+        </p:spPr>
+        <p:style>
+          <a:lnRef idx="1">
+            <a:schemeClr val="accent1"/>
+          </a:lnRef>
+          <a:fillRef idx="3">
+            <a:schemeClr val="accent1"/>
+          </a:fillRef>
+          <a:effectRef idx="2">
+            <a:schemeClr val="accent1"/>
+          </a:effectRef>
+          <a:fontRef idx="minor">
+            <a:schemeClr val="lt1"/>
+          </a:fontRef>
+        </p:style>
+        <p:txBody>
+          <a:bodyPr rtlCol="0" anchor="ctr"/>
+          <a:lstStyle/>
+          <a:p>
+            <a:pPr algn="ctr"/>
+          </a:p>
+        </p:txBody>
+      </p:sp>
+      <p:sp>
+        <p:nvSpPr>
+          <p:cNvPr id="3" name="Rectangle 2"/>
+          <p:cNvSpPr/>
+          <p:nvPr/>
+        </p:nvSpPr>
+        <p:spPr>
+          <a:xfrm>
+            <a:off x="0" y="0"/>
+            <a:ext cx="12188952" cy="50292"/>
+          </a:xfrm>
+          <a:prstGeom prst="rect">
+            <a:avLst/>
+          </a:prstGeom>
+          <a:solidFill>
+            <a:srgbClr val="1F2C56"/>
+          </a:solidFill>
+          <a:ln>
+            <a:noFill/>
+          </a:ln>
+        </p:spPr>
+        <p:style>
+          <a:lnRef idx="1">
+            <a:schemeClr val="accent1"/>
+          </a:lnRef>
+          <a:fillRef idx="3">
+            <a:schemeClr val="accent1"/>
+          </a:fillRef>
+          <a:effectRef idx="2">
+            <a:schemeClr val="accent1"/>
+          </a:effectRef>
+          <a:fontRef idx="minor">
+            <a:schemeClr val="lt1"/>
+          </a:fontRef>
+        </p:style>
+        <p:txBody>
+          <a:bodyPr rtlCol="0" anchor="ctr"/>
+          <a:lstStyle/>
+          <a:p>
+            <a:pPr algn="ctr"/>
+          </a:p>
+        </p:txBody>
+      </p:sp>
+      <p:sp>
+        <p:nvSpPr>
+          <p:cNvPr id="4" name="TextBox 3"/>
+          <p:cNvSpPr txBox="1"/>
+          <p:nvPr/>
+        </p:nvSpPr>
+        <p:spPr>
+          <a:xfrm>
+            <a:off x="685800" y="109728"/>
+            <a:ext cx="10817352" cy="228600"/>
+          </a:xfrm>
+          <a:prstGeom prst="rect">
+            <a:avLst/>
+          </a:prstGeom>
+          <a:noFill/>
+        </p:spPr>
+        <p:txBody>
+          <a:bodyPr wrap="none">
+            <a:spAutoFit/>
+          </a:bodyPr>
+          <a:lstStyle/>
+          <a:p>
+            <a:pPr algn="l"/>
+            <a:r>
+              <a:rPr sz="750">
+                <a:solidFill>
+                  <a:srgbClr val="78808C"/>
+                </a:solidFill>
+                <a:latin typeface="Consolas"/>
+              </a:rPr>
+              <a:t>VA02  ·  INHALT</a:t>
+            </a:r>
+          </a:p>
+        </p:txBody>
+      </p:sp>
+      <p:sp>
+        <p:nvSpPr>
+          <p:cNvPr id="5" name="Rectangle 4"/>
+          <p:cNvSpPr/>
+          <p:nvPr/>
+        </p:nvSpPr>
+        <p:spPr>
+          <a:xfrm>
+            <a:off x="0" y="1234440"/>
+            <a:ext cx="12188952" cy="12700"/>
+          </a:xfrm>
+          <a:prstGeom prst="rect">
+            <a:avLst/>
+          </a:prstGeom>
+          <a:solidFill>
+            <a:srgbClr val="D8DFE4"/>
+          </a:solidFill>
+          <a:ln>
+            <a:noFill/>
+          </a:ln>
+        </p:spPr>
+        <p:style>
+          <a:lnRef idx="1">
+            <a:schemeClr val="accent1"/>
+          </a:lnRef>
+          <a:fillRef idx="3">
+            <a:schemeClr val="accent1"/>
+          </a:fillRef>
+          <a:effectRef idx="2">
+            <a:schemeClr val="accent1"/>
+          </a:effectRef>
+          <a:fontRef idx="minor">
+            <a:schemeClr val="lt1"/>
+          </a:fontRef>
+        </p:style>
+        <p:txBody>
+          <a:bodyPr rtlCol="0" anchor="ctr"/>
+          <a:lstStyle/>
+          <a:p>
+            <a:pPr algn="ctr"/>
+          </a:p>
+        </p:txBody>
+      </p:sp>
+      <p:sp>
+        <p:nvSpPr>
+          <p:cNvPr id="6" name="Rectangle 5"/>
+          <p:cNvSpPr/>
+          <p:nvPr/>
+        </p:nvSpPr>
+        <p:spPr>
+          <a:xfrm>
+            <a:off x="685800" y="502920"/>
+            <a:ext cx="36576" cy="658368"/>
+          </a:xfrm>
+          <a:prstGeom prst="rect">
+            <a:avLst/>
+          </a:prstGeom>
+          <a:solidFill>
+            <a:srgbClr val="D9C089"/>
+          </a:solidFill>
+          <a:ln>
+            <a:noFill/>
+          </a:ln>
+        </p:spPr>
+        <p:style>
+          <a:lnRef idx="1">
+            <a:schemeClr val="accent1"/>
+          </a:lnRef>
+          <a:fillRef idx="3">
+            <a:schemeClr val="accent1"/>
+          </a:fillRef>
+          <a:effectRef idx="2">
+            <a:schemeClr val="accent1"/>
+          </a:effectRef>
+          <a:fontRef idx="minor">
+            <a:schemeClr val="lt1"/>
+          </a:fontRef>
+        </p:style>
+        <p:txBody>
+          <a:bodyPr rtlCol="0" anchor="ctr"/>
+          <a:lstStyle/>
+          <a:p>
+            <a:pPr algn="ctr"/>
+          </a:p>
+        </p:txBody>
+      </p:sp>
+      <p:sp>
+        <p:nvSpPr>
+          <p:cNvPr id="7" name="TextBox 6"/>
+          <p:cNvSpPr txBox="1"/>
+          <p:nvPr/>
+        </p:nvSpPr>
+        <p:spPr>
+          <a:xfrm>
+            <a:off x="813816" y="502920"/>
+            <a:ext cx="10634472" cy="685800"/>
+          </a:xfrm>
+          <a:prstGeom prst="rect">
+            <a:avLst/>
+          </a:prstGeom>
+          <a:noFill/>
+        </p:spPr>
+        <p:txBody>
+          <a:bodyPr wrap="square">
+            <a:spAutoFit/>
+          </a:bodyPr>
+          <a:lstStyle/>
+          <a:p>
+            <a:pPr algn="l"/>
+            <a:r>
+              <a:rPr sz="2400" b="1" i="0">
+                <a:solidFill>
+                  <a:srgbClr val="1F2C56"/>
+                </a:solidFill>
+                <a:latin typeface="Arial"/>
+              </a:rPr>
+              <a:t>Reflexionsfragen</a:t>
+            </a:r>
+          </a:p>
+        </p:txBody>
+      </p:sp>
+      <p:sp>
+        <p:nvSpPr>
+          <p:cNvPr id="8" name="TextBox 7"/>
+          <p:cNvSpPr txBox="1"/>
+          <p:nvPr/>
+        </p:nvSpPr>
+        <p:spPr>
+          <a:xfrm>
+            <a:off x="685800" y="1417320"/>
+            <a:ext cx="10817352" cy="4892040"/>
+          </a:xfrm>
+          <a:prstGeom prst="rect">
+            <a:avLst/>
+          </a:prstGeom>
+          <a:noFill/>
+        </p:spPr>
+        <p:txBody>
+          <a:bodyPr wrap="square" anchor="ctr">
+            <a:spAutoFit/>
+          </a:bodyPr>
+          <a:lstStyle/>
+          <a:p>
+            <a:pPr marL="190500" indent="-190500">
+              <a:spcBef>
+                <a:spcPts val="400"/>
+              </a:spcBef>
+              <a:spcAft>
+                <a:spcPts val="200"/>
+              </a:spcAft>
+            </a:pPr>
+            <a:r>
+              <a:rPr sz="1300">
+                <a:solidFill>
+                  <a:srgbClr val="3D5466"/>
+                </a:solidFill>
+                <a:latin typeface="Arial"/>
+              </a:rPr>
+              <a:t>▸  Bei welcher Sicherheit ist Ihnen die formale Bestellung am wenigsten klar – und wen fragen Sie?</a:t>
+            </a:r>
+          </a:p>
+          <a:p>
+            <a:pPr marL="190500" indent="-190500">
+              <a:spcBef>
+                <a:spcPts val="400"/>
+              </a:spcBef>
+              <a:spcAft>
+                <a:spcPts val="200"/>
+              </a:spcAft>
+            </a:pPr>
+            <a:r>
+              <a:rPr sz="1300">
+                <a:solidFill>
+                  <a:srgbClr val="3D5466"/>
+                </a:solidFill>
+                <a:latin typeface="Arial"/>
+              </a:rPr>
+              <a:t>▸  Wie formulieren Sie eine Eskalation, ohne dass sie wie eine Blockade wirkt?</a:t>
+            </a:r>
+          </a:p>
+          <a:p>
+            <a:pPr marL="190500" indent="-190500">
+              <a:spcBef>
+                <a:spcPts val="400"/>
+              </a:spcBef>
+              <a:spcAft>
+                <a:spcPts val="200"/>
+              </a:spcAft>
+            </a:pPr>
+            <a:r>
+              <a:rPr sz="1300">
+                <a:solidFill>
+                  <a:srgbClr val="3D5466"/>
+                </a:solidFill>
+                <a:latin typeface="Arial"/>
+              </a:rPr>
+              <a:t>▸  Woran erkennen Sie, dass eine Auszahlung trotz „vollständiger" Akte noch nicht freigabereif ist?</a:t>
+            </a:r>
+          </a:p>
+        </p:txBody>
+      </p:sp>
+      <p:sp>
+        <p:nvSpPr>
+          <p:cNvPr id="9" name="Rectangle 8"/>
+          <p:cNvSpPr/>
+          <p:nvPr/>
+        </p:nvSpPr>
+        <p:spPr>
+          <a:xfrm>
+            <a:off x="0" y="6510528"/>
+            <a:ext cx="12188952" cy="347472"/>
+          </a:xfrm>
+          <a:prstGeom prst="rect">
+            <a:avLst/>
+          </a:prstGeom>
+          <a:solidFill>
+            <a:srgbClr val="0A1937"/>
+          </a:solidFill>
+          <a:ln>
+            <a:noFill/>
+          </a:ln>
+        </p:spPr>
+        <p:style>
+          <a:lnRef idx="1">
+            <a:schemeClr val="accent1"/>
+          </a:lnRef>
+          <a:fillRef idx="3">
+            <a:schemeClr val="accent1"/>
+          </a:fillRef>
+          <a:effectRef idx="2">
+            <a:schemeClr val="accent1"/>
+          </a:effectRef>
+          <a:fontRef idx="minor">
+            <a:schemeClr val="lt1"/>
+          </a:fontRef>
+        </p:style>
+        <p:txBody>
+          <a:bodyPr rtlCol="0" anchor="ctr"/>
+          <a:lstStyle/>
+          <a:p>
+            <a:pPr algn="ctr"/>
+          </a:p>
+        </p:txBody>
+      </p:sp>
+      <p:sp>
+        <p:nvSpPr>
+          <p:cNvPr id="10" name="TextBox 9"/>
+          <p:cNvSpPr txBox="1"/>
+          <p:nvPr/>
+        </p:nvSpPr>
+        <p:spPr>
+          <a:xfrm>
+            <a:off x="685800" y="6583680"/>
+            <a:ext cx="6490411" cy="256032"/>
+          </a:xfrm>
+          <a:prstGeom prst="rect">
+            <a:avLst/>
+          </a:prstGeom>
+          <a:noFill/>
+        </p:spPr>
+        <p:txBody>
+          <a:bodyPr wrap="none">
+            <a:spAutoFit/>
+          </a:bodyPr>
+          <a:lstStyle/>
+          <a:p>
+            <a:pPr algn="l"/>
+            <a:r>
+              <a:rPr sz="700">
+                <a:solidFill>
+                  <a:srgbClr val="A0B4D2"/>
+                </a:solidFill>
+                <a:latin typeface="Consolas"/>
+              </a:rPr>
+              <a:t>FKB Campus  ·  VA02</a:t>
+            </a:r>
+          </a:p>
+        </p:txBody>
+      </p:sp>
+    </p:spTree>
+  </p:cSld>
+  <p:clrMapOvr>
+    <a:masterClrMapping/>
+  </p:clrMapOvr>
+</p:sld>
+</file>
+
 <file path=ppt/slides/slide2.xml><?xml version="1.0" encoding="utf-8"?>
 <p:sld xmlns:a="http://schemas.openxmlformats.org/drawingml/2006/main" xmlns:p="http://schemas.openxmlformats.org/presentationml/2006/main" xmlns:r="http://schemas.openxmlformats.org/officeDocument/2006/relationships">
   <p:cSld>
@@ -5830,7 +8917,7 @@
             <a:avLst/>
           </a:prstGeom>
           <a:solidFill>
-            <a:srgbClr val="EDEDF3"/>
+            <a:srgbClr val="1F2C56"/>
           </a:solidFill>
           <a:ln>
             <a:noFill/>
@@ -5860,57 +8947,14 @@
       </p:sp>
       <p:sp>
         <p:nvSpPr>
-          <p:cNvPr id="3" name="Rectangle 2"/>
-          <p:cNvSpPr/>
-          <p:nvPr/>
-        </p:nvSpPr>
-        <p:spPr>
-          <a:xfrm>
-            <a:off x="0" y="0"/>
-            <a:ext cx="12188952" cy="50292"/>
-          </a:xfrm>
-          <a:prstGeom prst="rect">
-            <a:avLst/>
-          </a:prstGeom>
-          <a:solidFill>
-            <a:srgbClr val="1F2C56"/>
-          </a:solidFill>
-          <a:ln>
-            <a:noFill/>
-          </a:ln>
-        </p:spPr>
-        <p:style>
-          <a:lnRef idx="1">
-            <a:schemeClr val="accent1"/>
-          </a:lnRef>
-          <a:fillRef idx="3">
-            <a:schemeClr val="accent1"/>
-          </a:fillRef>
-          <a:effectRef idx="2">
-            <a:schemeClr val="accent1"/>
-          </a:effectRef>
-          <a:fontRef idx="minor">
-            <a:schemeClr val="lt1"/>
-          </a:fontRef>
-        </p:style>
-        <p:txBody>
-          <a:bodyPr rtlCol="0" anchor="ctr"/>
-          <a:lstStyle/>
-          <a:p>
-            <a:pPr algn="ctr"/>
-          </a:p>
-        </p:txBody>
-      </p:sp>
-      <p:sp>
-        <p:nvSpPr>
-          <p:cNvPr id="4" name="TextBox 3"/>
+          <p:cNvPr id="3" name="TextBox 2"/>
           <p:cNvSpPr txBox="1"/>
           <p:nvPr/>
         </p:nvSpPr>
         <p:spPr>
           <a:xfrm>
-            <a:off x="685800" y="109728"/>
-            <a:ext cx="10817352" cy="228600"/>
+            <a:off x="685800" y="2377440"/>
+            <a:ext cx="10817352" cy="365760"/>
           </a:xfrm>
           <a:prstGeom prst="rect">
             <a:avLst/>
@@ -5925,70 +8969,27 @@
           <a:p>
             <a:pPr algn="l"/>
             <a:r>
-              <a:rPr sz="750">
-                <a:solidFill>
-                  <a:srgbClr val="78808C"/>
+              <a:rPr sz="1200">
+                <a:solidFill>
+                  <a:srgbClr val="D9C089"/>
                 </a:solidFill>
                 <a:latin typeface="Consolas"/>
               </a:rPr>
-              <a:t>VA02  ·  INHALT</a:t>
-            </a:r>
-          </a:p>
-        </p:txBody>
-      </p:sp>
-      <p:sp>
-        <p:nvSpPr>
-          <p:cNvPr id="5" name="Rectangle 4"/>
+              <a:t>00:05–00:20</a:t>
+            </a:r>
+          </a:p>
+        </p:txBody>
+      </p:sp>
+      <p:sp>
+        <p:nvSpPr>
+          <p:cNvPr id="4" name="Rectangle 3"/>
           <p:cNvSpPr/>
           <p:nvPr/>
         </p:nvSpPr>
         <p:spPr>
           <a:xfrm>
-            <a:off x="0" y="1234440"/>
-            <a:ext cx="12188952" cy="12700"/>
-          </a:xfrm>
-          <a:prstGeom prst="rect">
-            <a:avLst/>
-          </a:prstGeom>
-          <a:solidFill>
-            <a:srgbClr val="D8DFE4"/>
-          </a:solidFill>
-          <a:ln>
-            <a:noFill/>
-          </a:ln>
-        </p:spPr>
-        <p:style>
-          <a:lnRef idx="1">
-            <a:schemeClr val="accent1"/>
-          </a:lnRef>
-          <a:fillRef idx="3">
-            <a:schemeClr val="accent1"/>
-          </a:fillRef>
-          <a:effectRef idx="2">
-            <a:schemeClr val="accent1"/>
-          </a:effectRef>
-          <a:fontRef idx="minor">
-            <a:schemeClr val="lt1"/>
-          </a:fontRef>
-        </p:style>
-        <p:txBody>
-          <a:bodyPr rtlCol="0" anchor="ctr"/>
-          <a:lstStyle/>
-          <a:p>
-            <a:pPr algn="ctr"/>
-          </a:p>
-        </p:txBody>
-      </p:sp>
-      <p:sp>
-        <p:nvSpPr>
-          <p:cNvPr id="6" name="Rectangle 5"/>
-          <p:cNvSpPr/>
-          <p:nvPr/>
-        </p:nvSpPr>
-        <p:spPr>
-          <a:xfrm>
-            <a:off x="685800" y="502920"/>
-            <a:ext cx="36576" cy="658368"/>
+            <a:off x="685800" y="2788920"/>
+            <a:ext cx="548640" cy="38100"/>
           </a:xfrm>
           <a:prstGeom prst="rect">
             <a:avLst/>
@@ -6024,14 +9025,14 @@
       </p:sp>
       <p:sp>
         <p:nvSpPr>
-          <p:cNvPr id="7" name="TextBox 6"/>
+          <p:cNvPr id="5" name="TextBox 4"/>
           <p:cNvSpPr txBox="1"/>
           <p:nvPr/>
         </p:nvSpPr>
         <p:spPr>
           <a:xfrm>
-            <a:off x="813816" y="502920"/>
-            <a:ext cx="10634472" cy="685800"/>
+            <a:off x="685800" y="3017520"/>
+            <a:ext cx="10817352" cy="1463040"/>
           </a:xfrm>
           <a:prstGeom prst="rect">
             <a:avLst/>
@@ -6046,27 +9047,27 @@
           <a:p>
             <a:pPr algn="l"/>
             <a:r>
-              <a:rPr sz="2400" b="1" i="0">
-                <a:solidFill>
-                  <a:srgbClr val="1F2C56"/>
+              <a:rPr sz="4000" b="1" i="0">
+                <a:solidFill>
+                  <a:srgbClr val="FFFFFF"/>
                 </a:solidFill>
                 <a:latin typeface="Arial"/>
               </a:rPr>
-              <a:t>Theorie-Input: Sicherheiten und ihre Unterlagen</a:t>
-            </a:r>
-          </a:p>
-        </p:txBody>
-      </p:sp>
-      <p:sp>
-        <p:nvSpPr>
-          <p:cNvPr id="8" name="TextBox 7"/>
+              <a:t>Theorie-Input 1</a:t>
+            </a:r>
+          </a:p>
+        </p:txBody>
+      </p:sp>
+      <p:sp>
+        <p:nvSpPr>
+          <p:cNvPr id="6" name="TextBox 5"/>
           <p:cNvSpPr txBox="1"/>
           <p:nvPr/>
         </p:nvSpPr>
         <p:spPr>
           <a:xfrm>
-            <a:off x="685800" y="1417320"/>
-            <a:ext cx="10817352" cy="4892040"/>
+            <a:off x="685800" y="4480560"/>
+            <a:ext cx="8653881" cy="1280160"/>
           </a:xfrm>
           <a:prstGeom prst="rect">
             <a:avLst/>
@@ -6074,84 +9075,34 @@
           <a:noFill/>
         </p:spPr>
         <p:txBody>
-          <a:bodyPr wrap="square" anchor="ctr">
+          <a:bodyPr wrap="square">
             <a:spAutoFit/>
           </a:bodyPr>
           <a:lstStyle/>
           <a:p>
-            <a:pPr marL="190500" indent="-190500">
-              <a:spcBef>
-                <a:spcPts val="400"/>
-              </a:spcBef>
-              <a:spcAft>
-                <a:spcPts val="200"/>
-              </a:spcAft>
-            </a:pPr>
-            <a:r>
-              <a:rPr sz="1300">
-                <a:solidFill>
-                  <a:srgbClr val="3D5466"/>
+            <a:pPr algn="l"/>
+            <a:r>
+              <a:rPr sz="1600" b="0" i="0">
+                <a:solidFill>
+                  <a:srgbClr val="C8D2E6"/>
                 </a:solidFill>
                 <a:latin typeface="Arial"/>
               </a:rPr>
-              <a:t>▸  Sicherheiten sind kein einmaliger Vorgang: Sie veralten und müssen turnusmäßig nachgehalten werden. Das schlägt die Brücke zur Fristensteuerung (VA04):</a:t>
-            </a:r>
-          </a:p>
-        </p:txBody>
-      </p:sp>
-      <p:sp>
-        <p:nvSpPr>
-          <p:cNvPr id="9" name="Rectangle 8"/>
-          <p:cNvSpPr/>
-          <p:nvPr/>
-        </p:nvSpPr>
-        <p:spPr>
-          <a:xfrm>
-            <a:off x="0" y="6510528"/>
-            <a:ext cx="12188952" cy="347472"/>
-          </a:xfrm>
-          <a:prstGeom prst="rect">
-            <a:avLst/>
-          </a:prstGeom>
-          <a:solidFill>
-            <a:srgbClr val="0A1937"/>
-          </a:solidFill>
-          <a:ln>
-            <a:noFill/>
-          </a:ln>
-        </p:spPr>
-        <p:style>
-          <a:lnRef idx="1">
-            <a:schemeClr val="accent1"/>
-          </a:lnRef>
-          <a:fillRef idx="3">
-            <a:schemeClr val="accent1"/>
-          </a:fillRef>
-          <a:effectRef idx="2">
-            <a:schemeClr val="accent1"/>
-          </a:effectRef>
-          <a:fontRef idx="minor">
-            <a:schemeClr val="lt1"/>
-          </a:fontRef>
-        </p:style>
-        <p:txBody>
-          <a:bodyPr rtlCol="0" anchor="ctr"/>
-          <a:lstStyle/>
-          <a:p>
-            <a:pPr algn="ctr"/>
-          </a:p>
-        </p:txBody>
-      </p:sp>
-      <p:sp>
-        <p:nvSpPr>
-          <p:cNvPr id="10" name="TextBox 9"/>
+              <a:t>Die fünf Sicherheitenarten und ihre Unterlagen sicher zuordnen.</a:t>
+            </a:r>
+          </a:p>
+        </p:txBody>
+      </p:sp>
+      <p:sp>
+        <p:nvSpPr>
+          <p:cNvPr id="7" name="TextBox 6"/>
           <p:cNvSpPr txBox="1"/>
           <p:nvPr/>
         </p:nvSpPr>
         <p:spPr>
           <a:xfrm>
-            <a:off x="685800" y="6583680"/>
-            <a:ext cx="6490411" cy="256032"/>
+            <a:off x="685800" y="6355080"/>
+            <a:ext cx="10817352" cy="274320"/>
           </a:xfrm>
           <a:prstGeom prst="rect">
             <a:avLst/>
@@ -6168,7 +9119,7 @@
             <a:r>
               <a:rPr sz="700">
                 <a:solidFill>
-                  <a:srgbClr val="A0B4D2"/>
+                  <a:srgbClr val="8CA0C3"/>
                 </a:solidFill>
                 <a:latin typeface="Consolas"/>
               </a:rPr>
@@ -6432,7 +9383,7 @@
                 </a:solidFill>
                 <a:latin typeface="Arial"/>
               </a:rPr>
-              <a:t>Theorie-Input: Auszahlungsvoraussetzungen</a:t>
+              <a:t>Sicherheiten: Realsicherheit oder Personalsicherheit</a:t>
             </a:r>
           </a:p>
         </p:txBody>
@@ -6458,6 +9409,25 @@
             <a:spAutoFit/>
           </a:bodyPr>
           <a:lstStyle/>
+          <a:p>
+            <a:pPr marL="177800" indent="-177800">
+              <a:spcBef>
+                <a:spcPts val="600"/>
+              </a:spcBef>
+              <a:spcAft>
+                <a:spcPts val="200"/>
+              </a:spcAft>
+            </a:pPr>
+            <a:r>
+              <a:rPr sz="1200" i="1">
+                <a:solidFill>
+                  <a:srgbClr val="3D5466"/>
+                </a:solidFill>
+                <a:latin typeface="Arial"/>
+              </a:rPr>
+              <a:t>→  Eine Sicherheit schützt die Bank nur, wenn sie formal korrekt bestellt und werthaltig ist – die Form entscheidet über die Wirksamkeit.</a:t>
+            </a:r>
+          </a:p>
           <a:p>
             <a:pPr marL="190500" indent="-190500">
               <a:spcBef>
@@ -6474,7 +9444,7 @@
                 </a:solidFill>
                 <a:latin typeface="Arial"/>
               </a:rPr>
-              <a:t>▸  Vor der Auszahlung prüft der Innendienst, ob alle vereinbarten Voraussetzungen erfüllt sind. Typisch sind:</a:t>
+              <a:t>▸  Realsicherheiten haften an einer Sache: Grundschuld, Sicherungsübereignung, Verpfändung.</a:t>
             </a:r>
           </a:p>
           <a:p>
@@ -6493,7 +9463,7 @@
                 </a:solidFill>
                 <a:latin typeface="Arial"/>
               </a:rPr>
-              <a:t>▸  Kreditvertrag rechtsverbindlich unterschrieben</a:t>
+              <a:t>▸  Personalsicherheiten haften an einer Person: die Bürgschaft (Schriftform zwingend, § 766 BGB – sonst nichtig).</a:t>
             </a:r>
           </a:p>
           <a:p>
@@ -6512,45 +9482,7 @@
                 </a:solidFill>
                 <a:latin typeface="Arial"/>
               </a:rPr>
-              <a:t>▸  vereinbarte Sicherheiten bestellt und nachgewiesen (z. B. Grundschuld eingetragen, Rang gesichert)</a:t>
-            </a:r>
-          </a:p>
-          <a:p>
-            <a:pPr marL="190500" indent="-190500">
-              <a:spcBef>
-                <a:spcPts val="400"/>
-              </a:spcBef>
-              <a:spcAft>
-                <a:spcPts val="200"/>
-              </a:spcAft>
-            </a:pPr>
-            <a:r>
-              <a:rPr sz="1300">
-                <a:solidFill>
-                  <a:srgbClr val="3D5466"/>
-                </a:solidFill>
-                <a:latin typeface="Arial"/>
-              </a:rPr>
-              <a:t>▸  Offenlegungsunterlagen vollständig (§ 18 KWG )</a:t>
-            </a:r>
-          </a:p>
-          <a:p>
-            <a:pPr marL="190500" indent="-190500">
-              <a:spcBef>
-                <a:spcPts val="400"/>
-              </a:spcBef>
-              <a:spcAft>
-                <a:spcPts val="200"/>
-              </a:spcAft>
-            </a:pPr>
-            <a:r>
-              <a:rPr sz="1300">
-                <a:solidFill>
-                  <a:srgbClr val="3D5466"/>
-                </a:solidFill>
-                <a:latin typeface="Arial"/>
-              </a:rPr>
-              <a:t>▸  besondere Auflagen aus dem Kreditbeschluss erfüllt (z. B. Eigenmittelnachweis, Verwendungsnachweis)</a:t>
+              <a:t>▸  Forderungssicherheiten treten Ansprüche ab: die Forderungsabtretung.</a:t>
             </a:r>
           </a:p>
         </p:txBody>
@@ -6666,7 +9598,7 @@
             <a:avLst/>
           </a:prstGeom>
           <a:solidFill>
-            <a:srgbClr val="EDEDF3"/>
+            <a:srgbClr val="FFFFFF"/>
           </a:solidFill>
           <a:ln>
             <a:noFill/>
@@ -6767,51 +9699,43 @@
                 </a:solidFill>
                 <a:latin typeface="Consolas"/>
               </a:rPr>
-              <a:t>VA02  ·  ARBEITSBLATT</a:t>
-            </a:r>
-          </a:p>
-        </p:txBody>
-      </p:sp>
-      <p:sp>
-        <p:nvSpPr>
-          <p:cNvPr id="5" name="Rectangle 4"/>
-          <p:cNvSpPr/>
-          <p:nvPr/>
-        </p:nvSpPr>
-        <p:spPr>
-          <a:xfrm>
-            <a:off x="0" y="1234440"/>
-            <a:ext cx="12188952" cy="12700"/>
-          </a:xfrm>
-          <a:prstGeom prst="rect">
-            <a:avLst/>
-          </a:prstGeom>
-          <a:solidFill>
-            <a:srgbClr val="D8DFE4"/>
-          </a:solidFill>
-          <a:ln>
-            <a:noFill/>
-          </a:ln>
-        </p:spPr>
-        <p:style>
-          <a:lnRef idx="1">
-            <a:schemeClr val="accent1"/>
-          </a:lnRef>
-          <a:fillRef idx="3">
-            <a:schemeClr val="accent1"/>
-          </a:fillRef>
-          <a:effectRef idx="2">
-            <a:schemeClr val="accent1"/>
-          </a:effectRef>
-          <a:fontRef idx="minor">
-            <a:schemeClr val="lt1"/>
-          </a:fontRef>
-        </p:style>
-        <p:txBody>
-          <a:bodyPr rtlCol="0" anchor="ctr"/>
-          <a:lstStyle/>
-          <a:p>
-            <a:pPr algn="ctr"/>
+              <a:t>VA02  ·  SCHAUBILD</a:t>
+            </a:r>
+          </a:p>
+        </p:txBody>
+      </p:sp>
+      <p:sp>
+        <p:nvSpPr>
+          <p:cNvPr id="5" name="TextBox 4"/>
+          <p:cNvSpPr txBox="1"/>
+          <p:nvPr/>
+        </p:nvSpPr>
+        <p:spPr>
+          <a:xfrm>
+            <a:off x="685800" y="502920"/>
+            <a:ext cx="10817352" cy="594360"/>
+          </a:xfrm>
+          <a:prstGeom prst="rect">
+            <a:avLst/>
+          </a:prstGeom>
+          <a:noFill/>
+        </p:spPr>
+        <p:txBody>
+          <a:bodyPr wrap="square">
+            <a:spAutoFit/>
+          </a:bodyPr>
+          <a:lstStyle/>
+          <a:p>
+            <a:pPr algn="l"/>
+            <a:r>
+              <a:rPr sz="2000" b="1" i="0">
+                <a:solidFill>
+                  <a:srgbClr val="1F2C56"/>
+                </a:solidFill>
+                <a:latin typeface="Arial"/>
+              </a:rPr>
+              <a:t>Sicherheitenarten und ihre Unterlagen</a:t>
+            </a:r>
           </a:p>
         </p:txBody>
       </p:sp>
@@ -6823,8 +9747,8 @@
         </p:nvSpPr>
         <p:spPr>
           <a:xfrm>
-            <a:off x="685800" y="502920"/>
-            <a:ext cx="36576" cy="658368"/>
+            <a:off x="685800" y="1143000"/>
+            <a:ext cx="10817352" cy="25400"/>
           </a:xfrm>
           <a:prstGeom prst="rect">
             <a:avLst/>
@@ -6858,240 +9782,33 @@
           </a:p>
         </p:txBody>
       </p:sp>
-      <p:sp>
-        <p:nvSpPr>
-          <p:cNvPr id="7" name="TextBox 6"/>
-          <p:cNvSpPr txBox="1"/>
-          <p:nvPr/>
-        </p:nvSpPr>
-        <p:spPr>
-          <a:xfrm>
-            <a:off x="813816" y="502920"/>
-            <a:ext cx="10634472" cy="685800"/>
-          </a:xfrm>
-          <a:prstGeom prst="rect">
-            <a:avLst/>
-          </a:prstGeom>
-          <a:noFill/>
-        </p:spPr>
-        <p:txBody>
-          <a:bodyPr wrap="square">
-            <a:spAutoFit/>
-          </a:bodyPr>
-          <a:lstStyle/>
-          <a:p>
-            <a:pPr algn="l"/>
-            <a:r>
-              <a:rPr sz="2400" b="1" i="0">
-                <a:solidFill>
-                  <a:srgbClr val="1F2C56"/>
-                </a:solidFill>
-                <a:latin typeface="Arial"/>
-              </a:rPr>
-              <a:t>Praxisfall: Auszahlung Bau Musterregion GmbH</a:t>
-            </a:r>
-          </a:p>
-        </p:txBody>
-      </p:sp>
-      <p:sp>
-        <p:nvSpPr>
-          <p:cNvPr id="8" name="TextBox 7"/>
-          <p:cNvSpPr txBox="1"/>
-          <p:nvPr/>
-        </p:nvSpPr>
-        <p:spPr>
-          <a:xfrm>
-            <a:off x="685800" y="1554480"/>
-            <a:ext cx="10817352" cy="3840480"/>
-          </a:xfrm>
-          <a:prstGeom prst="rect">
-            <a:avLst/>
-          </a:prstGeom>
-          <a:noFill/>
-        </p:spPr>
-        <p:txBody>
-          <a:bodyPr wrap="square">
-            <a:spAutoFit/>
-          </a:bodyPr>
-          <a:lstStyle/>
-          <a:p>
-            <a:pPr marL="190500" indent="-190500">
-              <a:spcBef>
-                <a:spcPts val="400"/>
-              </a:spcBef>
-              <a:spcAft>
-                <a:spcPts val="200"/>
-              </a:spcAft>
-            </a:pPr>
-            <a:r>
-              <a:rPr sz="1400">
-                <a:solidFill>
-                  <a:srgbClr val="3D5466"/>
-                </a:solidFill>
-                <a:latin typeface="Arial"/>
-              </a:rPr>
-              <a:t>▸  Ausgangslage (anonymisiert)</a:t>
-            </a:r>
-          </a:p>
-          <a:p>
-            <a:pPr marL="190500" indent="-190500">
-              <a:spcBef>
-                <a:spcPts val="400"/>
-              </a:spcBef>
-              <a:spcAft>
-                <a:spcPts val="200"/>
-              </a:spcAft>
-            </a:pPr>
-            <a:r>
-              <a:rPr sz="1400">
-                <a:solidFill>
-                  <a:srgbClr val="3D5466"/>
-                </a:solidFill>
-                <a:latin typeface="Arial"/>
-              </a:rPr>
-              <a:t>▸  Vorliegende Unterlagen:</a:t>
-            </a:r>
-          </a:p>
-          <a:p>
-            <a:pPr marL="190500" indent="-190500">
-              <a:spcBef>
-                <a:spcPts val="400"/>
-              </a:spcBef>
-              <a:spcAft>
-                <a:spcPts val="200"/>
-              </a:spcAft>
-            </a:pPr>
-            <a:r>
-              <a:rPr sz="1400">
-                <a:solidFill>
-                  <a:srgbClr val="3D5466"/>
-                </a:solidFill>
-                <a:latin typeface="Arial"/>
-              </a:rPr>
-              <a:t>▸  Sicherheiten und Unterlagen zuordnen</a:t>
-            </a:r>
-          </a:p>
-          <a:p>
-            <a:pPr marL="190500" indent="-190500">
-              <a:spcBef>
-                <a:spcPts val="400"/>
-              </a:spcBef>
-              <a:spcAft>
-                <a:spcPts val="200"/>
-              </a:spcAft>
-            </a:pPr>
-            <a:r>
-              <a:rPr sz="1400">
-                <a:solidFill>
-                  <a:srgbClr val="3D5466"/>
-                </a:solidFill>
-                <a:latin typeface="Arial"/>
-              </a:rPr>
-              <a:t>▸  Anleitung: Ordnen Sie den beiden Sicherheiten des Falls die nötigen Nachweise zu und markieren Sie, was vorliegt.</a:t>
-            </a:r>
-          </a:p>
-          <a:p>
-            <a:pPr marL="190500" indent="-190500">
-              <a:spcBef>
-                <a:spcPts val="400"/>
-              </a:spcBef>
-              <a:spcAft>
-                <a:spcPts val="200"/>
-              </a:spcAft>
-            </a:pPr>
-            <a:r>
-              <a:rPr sz="1400">
-                <a:solidFill>
-                  <a:srgbClr val="3D5466"/>
-                </a:solidFill>
-                <a:latin typeface="Arial"/>
-              </a:rPr>
-              <a:t>▸  Auszahlungsvoraussetzungen prüfen</a:t>
-            </a:r>
-          </a:p>
-        </p:txBody>
-      </p:sp>
-      <p:sp>
-        <p:nvSpPr>
-          <p:cNvPr id="9" name="Rectangle 8"/>
-          <p:cNvSpPr/>
-          <p:nvPr/>
-        </p:nvSpPr>
-        <p:spPr>
-          <a:xfrm>
-            <a:off x="685800" y="5486400"/>
-            <a:ext cx="10817352" cy="640080"/>
-          </a:xfrm>
-          <a:prstGeom prst="rect">
-            <a:avLst/>
-          </a:prstGeom>
-          <a:solidFill>
-            <a:srgbClr val="1F2C56"/>
-          </a:solidFill>
-          <a:ln>
-            <a:noFill/>
-          </a:ln>
-        </p:spPr>
-        <p:style>
-          <a:lnRef idx="1">
-            <a:schemeClr val="accent1"/>
-          </a:lnRef>
-          <a:fillRef idx="3">
-            <a:schemeClr val="accent1"/>
-          </a:fillRef>
-          <a:effectRef idx="2">
-            <a:schemeClr val="accent1"/>
-          </a:effectRef>
-          <a:fontRef idx="minor">
-            <a:schemeClr val="lt1"/>
-          </a:fontRef>
-        </p:style>
-        <p:txBody>
-          <a:bodyPr rtlCol="0" anchor="ctr"/>
-          <a:lstStyle/>
-          <a:p>
-            <a:pPr algn="ctr"/>
-          </a:p>
-        </p:txBody>
-      </p:sp>
-      <p:sp>
-        <p:nvSpPr>
-          <p:cNvPr id="10" name="TextBox 9"/>
-          <p:cNvSpPr txBox="1"/>
-          <p:nvPr/>
-        </p:nvSpPr>
-        <p:spPr>
-          <a:xfrm>
-            <a:off x="868680" y="5596128"/>
-            <a:ext cx="10451592" cy="457200"/>
-          </a:xfrm>
-          <a:prstGeom prst="rect">
-            <a:avLst/>
-          </a:prstGeom>
-          <a:noFill/>
-        </p:spPr>
-        <p:txBody>
-          <a:bodyPr wrap="square">
-            <a:spAutoFit/>
-          </a:bodyPr>
-          <a:lstStyle/>
-          <a:p>
-            <a:pPr algn="l"/>
-            <a:r>
-              <a:rPr sz="1300" b="1" i="0">
-                <a:solidFill>
-                  <a:srgbClr val="FFFFFF"/>
-                </a:solidFill>
-                <a:latin typeface="Arial"/>
-              </a:rPr>
-              <a:t>→  Bearbeitung im Teilnehmer-Workbook (Arbeitsblatt mit Ausfüllfeldern)</a:t>
-            </a:r>
-          </a:p>
-        </p:txBody>
-      </p:sp>
-      <p:sp>
-        <p:nvSpPr>
-          <p:cNvPr id="11" name="Rectangle 10"/>
+      <p:pic>
+        <p:nvPicPr>
+          <p:cNvPr id="7" name="Picture 6" descr="image.png"/>
+          <p:cNvPicPr>
+            <a:picLocks noChangeAspect="1"/>
+          </p:cNvPicPr>
+          <p:nvPr/>
+        </p:nvPicPr>
+        <p:blipFill>
+          <a:blip r:embed="rId2"/>
+          <a:stretch>
+            <a:fillRect/>
+          </a:stretch>
+        </p:blipFill>
+        <p:spPr>
+          <a:xfrm>
+            <a:off x="2009463" y="1325880"/>
+            <a:ext cx="8170026" cy="4937760"/>
+          </a:xfrm>
+          <a:prstGeom prst="rect">
+            <a:avLst/>
+          </a:prstGeom>
+        </p:spPr>
+      </p:pic>
+      <p:sp>
+        <p:nvSpPr>
+          <p:cNvPr id="8" name="Rectangle 7"/>
           <p:cNvSpPr/>
           <p:nvPr/>
         </p:nvSpPr>
@@ -7134,7 +9851,7 @@
       </p:sp>
       <p:sp>
         <p:nvSpPr>
-          <p:cNvPr id="12" name="TextBox 11"/>
+          <p:cNvPr id="9" name="TextBox 8"/>
           <p:cNvSpPr txBox="1"/>
           <p:nvPr/>
         </p:nvSpPr>
@@ -7163,6 +9880,41 @@
                 <a:latin typeface="Consolas"/>
               </a:rPr>
               <a:t>FKB Campus  ·  VA02</a:t>
+            </a:r>
+          </a:p>
+        </p:txBody>
+      </p:sp>
+      <p:sp>
+        <p:nvSpPr>
+          <p:cNvPr id="10" name="TextBox 9"/>
+          <p:cNvSpPr txBox="1"/>
+          <p:nvPr/>
+        </p:nvSpPr>
+        <p:spPr>
+          <a:xfrm>
+            <a:off x="7176211" y="6583680"/>
+            <a:ext cx="4326940" cy="256032"/>
+          </a:xfrm>
+          <a:prstGeom prst="rect">
+            <a:avLst/>
+          </a:prstGeom>
+          <a:noFill/>
+        </p:spPr>
+        <p:txBody>
+          <a:bodyPr wrap="none">
+            <a:spAutoFit/>
+          </a:bodyPr>
+          <a:lstStyle/>
+          <a:p>
+            <a:pPr algn="r"/>
+            <a:r>
+              <a:rPr sz="700">
+                <a:solidFill>
+                  <a:srgbClr val="A0B4D2"/>
+                </a:solidFill>
+                <a:latin typeface="Consolas"/>
+              </a:rPr>
+              <a:t>Schaubild</a:t>
             </a:r>
           </a:p>
         </p:txBody>
@@ -7200,6 +9952,250 @@
             <a:avLst/>
           </a:prstGeom>
           <a:solidFill>
+            <a:srgbClr val="1F2C56"/>
+          </a:solidFill>
+          <a:ln>
+            <a:noFill/>
+          </a:ln>
+        </p:spPr>
+        <p:style>
+          <a:lnRef idx="1">
+            <a:schemeClr val="accent1"/>
+          </a:lnRef>
+          <a:fillRef idx="3">
+            <a:schemeClr val="accent1"/>
+          </a:fillRef>
+          <a:effectRef idx="2">
+            <a:schemeClr val="accent1"/>
+          </a:effectRef>
+          <a:fontRef idx="minor">
+            <a:schemeClr val="lt1"/>
+          </a:fontRef>
+        </p:style>
+        <p:txBody>
+          <a:bodyPr rtlCol="0" anchor="ctr"/>
+          <a:lstStyle/>
+          <a:p>
+            <a:pPr algn="ctr"/>
+          </a:p>
+        </p:txBody>
+      </p:sp>
+      <p:sp>
+        <p:nvSpPr>
+          <p:cNvPr id="3" name="TextBox 2"/>
+          <p:cNvSpPr txBox="1"/>
+          <p:nvPr/>
+        </p:nvSpPr>
+        <p:spPr>
+          <a:xfrm>
+            <a:off x="685800" y="2377440"/>
+            <a:ext cx="10817352" cy="365760"/>
+          </a:xfrm>
+          <a:prstGeom prst="rect">
+            <a:avLst/>
+          </a:prstGeom>
+          <a:noFill/>
+        </p:spPr>
+        <p:txBody>
+          <a:bodyPr wrap="none">
+            <a:spAutoFit/>
+          </a:bodyPr>
+          <a:lstStyle/>
+          <a:p>
+            <a:pPr algn="l"/>
+            <a:r>
+              <a:rPr sz="1200">
+                <a:solidFill>
+                  <a:srgbClr val="D9C089"/>
+                </a:solidFill>
+                <a:latin typeface="Consolas"/>
+              </a:rPr>
+              <a:t>00:20–00:30</a:t>
+            </a:r>
+          </a:p>
+        </p:txBody>
+      </p:sp>
+      <p:sp>
+        <p:nvSpPr>
+          <p:cNvPr id="4" name="Rectangle 3"/>
+          <p:cNvSpPr/>
+          <p:nvPr/>
+        </p:nvSpPr>
+        <p:spPr>
+          <a:xfrm>
+            <a:off x="685800" y="2788920"/>
+            <a:ext cx="548640" cy="38100"/>
+          </a:xfrm>
+          <a:prstGeom prst="rect">
+            <a:avLst/>
+          </a:prstGeom>
+          <a:solidFill>
+            <a:srgbClr val="D9C089"/>
+          </a:solidFill>
+          <a:ln>
+            <a:noFill/>
+          </a:ln>
+        </p:spPr>
+        <p:style>
+          <a:lnRef idx="1">
+            <a:schemeClr val="accent1"/>
+          </a:lnRef>
+          <a:fillRef idx="3">
+            <a:schemeClr val="accent1"/>
+          </a:fillRef>
+          <a:effectRef idx="2">
+            <a:schemeClr val="accent1"/>
+          </a:effectRef>
+          <a:fontRef idx="minor">
+            <a:schemeClr val="lt1"/>
+          </a:fontRef>
+        </p:style>
+        <p:txBody>
+          <a:bodyPr rtlCol="0" anchor="ctr"/>
+          <a:lstStyle/>
+          <a:p>
+            <a:pPr algn="ctr"/>
+          </a:p>
+        </p:txBody>
+      </p:sp>
+      <p:sp>
+        <p:nvSpPr>
+          <p:cNvPr id="5" name="TextBox 4"/>
+          <p:cNvSpPr txBox="1"/>
+          <p:nvPr/>
+        </p:nvSpPr>
+        <p:spPr>
+          <a:xfrm>
+            <a:off x="685800" y="3017520"/>
+            <a:ext cx="10817352" cy="1463040"/>
+          </a:xfrm>
+          <a:prstGeom prst="rect">
+            <a:avLst/>
+          </a:prstGeom>
+          <a:noFill/>
+        </p:spPr>
+        <p:txBody>
+          <a:bodyPr wrap="square">
+            <a:spAutoFit/>
+          </a:bodyPr>
+          <a:lstStyle/>
+          <a:p>
+            <a:pPr algn="l"/>
+            <a:r>
+              <a:rPr sz="4000" b="1" i="0">
+                <a:solidFill>
+                  <a:srgbClr val="FFFFFF"/>
+                </a:solidFill>
+                <a:latin typeface="Arial"/>
+              </a:rPr>
+              <a:t>Theorie-Input 2</a:t>
+            </a:r>
+          </a:p>
+        </p:txBody>
+      </p:sp>
+      <p:sp>
+        <p:nvSpPr>
+          <p:cNvPr id="6" name="TextBox 5"/>
+          <p:cNvSpPr txBox="1"/>
+          <p:nvPr/>
+        </p:nvSpPr>
+        <p:spPr>
+          <a:xfrm>
+            <a:off x="685800" y="4480560"/>
+            <a:ext cx="8653881" cy="1280160"/>
+          </a:xfrm>
+          <a:prstGeom prst="rect">
+            <a:avLst/>
+          </a:prstGeom>
+          <a:noFill/>
+        </p:spPr>
+        <p:txBody>
+          <a:bodyPr wrap="square">
+            <a:spAutoFit/>
+          </a:bodyPr>
+          <a:lstStyle/>
+          <a:p>
+            <a:pPr algn="l"/>
+            <a:r>
+              <a:rPr sz="1600" b="0" i="0">
+                <a:solidFill>
+                  <a:srgbClr val="C8D2E6"/>
+                </a:solidFill>
+                <a:latin typeface="Arial"/>
+              </a:rPr>
+              <a:t>Die Auszahlungsvoraussetzungen prüfen – und die eigene Kompetenzgrenze kennen.</a:t>
+            </a:r>
+          </a:p>
+        </p:txBody>
+      </p:sp>
+      <p:sp>
+        <p:nvSpPr>
+          <p:cNvPr id="7" name="TextBox 6"/>
+          <p:cNvSpPr txBox="1"/>
+          <p:nvPr/>
+        </p:nvSpPr>
+        <p:spPr>
+          <a:xfrm>
+            <a:off x="685800" y="6355080"/>
+            <a:ext cx="10817352" cy="274320"/>
+          </a:xfrm>
+          <a:prstGeom prst="rect">
+            <a:avLst/>
+          </a:prstGeom>
+          <a:noFill/>
+        </p:spPr>
+        <p:txBody>
+          <a:bodyPr wrap="none">
+            <a:spAutoFit/>
+          </a:bodyPr>
+          <a:lstStyle/>
+          <a:p>
+            <a:pPr algn="l"/>
+            <a:r>
+              <a:rPr sz="700">
+                <a:solidFill>
+                  <a:srgbClr val="8CA0C3"/>
+                </a:solidFill>
+                <a:latin typeface="Consolas"/>
+              </a:rPr>
+              <a:t>FKB Campus  ·  VA02</a:t>
+            </a:r>
+          </a:p>
+        </p:txBody>
+      </p:sp>
+    </p:spTree>
+  </p:cSld>
+  <p:clrMapOvr>
+    <a:masterClrMapping/>
+  </p:clrMapOvr>
+</p:sld>
+</file>
+
+<file path=ppt/slides/slide9.xml><?xml version="1.0" encoding="utf-8"?>
+<p:sld xmlns:a="http://schemas.openxmlformats.org/drawingml/2006/main" xmlns:p="http://schemas.openxmlformats.org/presentationml/2006/main" xmlns:r="http://schemas.openxmlformats.org/officeDocument/2006/relationships">
+  <p:cSld>
+    <p:spTree>
+      <p:nvGrpSpPr>
+        <p:cNvPr id="1" name=""/>
+        <p:cNvGrpSpPr/>
+        <p:nvPr/>
+      </p:nvGrpSpPr>
+      <p:grpSpPr/>
+      <p:sp>
+        <p:nvSpPr>
+          <p:cNvPr id="2" name="Rectangle 1"/>
+          <p:cNvSpPr/>
+          <p:nvPr/>
+        </p:nvSpPr>
+        <p:spPr>
+          <a:xfrm>
+            <a:off x="0" y="0"/>
+            <a:ext cx="12188952" cy="6858000"/>
+          </a:xfrm>
+          <a:prstGeom prst="rect">
+            <a:avLst/>
+          </a:prstGeom>
+          <a:solidFill>
             <a:srgbClr val="EDEDF3"/>
           </a:solidFill>
           <a:ln>
@@ -7422,7 +10418,7 @@
                 </a:solidFill>
                 <a:latin typeface="Arial"/>
               </a:rPr>
-              <a:t>Reflexionsfragen</a:t>
+              <a:t>Auszahlungsvoraussetzungen und Kompetenzgrenzen</a:t>
             </a:r>
           </a:p>
         </p:txBody>
@@ -7444,10 +10440,48 @@
           <a:noFill/>
         </p:spPr>
         <p:txBody>
-          <a:bodyPr wrap="square" anchor="ctr">
+          <a:bodyPr wrap="square">
             <a:spAutoFit/>
           </a:bodyPr>
           <a:lstStyle/>
+          <a:p>
+            <a:pPr marL="177800" indent="-177800">
+              <a:spcBef>
+                <a:spcPts val="600"/>
+              </a:spcBef>
+              <a:spcAft>
+                <a:spcPts val="200"/>
+              </a:spcAft>
+            </a:pPr>
+            <a:r>
+              <a:rPr sz="1200" i="1">
+                <a:solidFill>
+                  <a:srgbClr val="3D5466"/>
+                </a:solidFill>
+                <a:latin typeface="Arial"/>
+              </a:rPr>
+              <a:t>→  Die Assistenz erkennt, dokumentiert und eskaliert – sie entscheidet nicht. Die Freigabe liegt bei der Marktfolge (MaRisk BTO 1.2).</a:t>
+            </a:r>
+          </a:p>
+          <a:p>
+            <a:pPr>
+              <a:spcBef>
+                <a:spcPts val="1000"/>
+              </a:spcBef>
+              <a:spcAft>
+                <a:spcPts val="200"/>
+              </a:spcAft>
+            </a:pPr>
+            <a:r>
+              <a:rPr sz="800" b="1">
+                <a:solidFill>
+                  <a:srgbClr val="78808C"/>
+                </a:solidFill>
+                <a:latin typeface="Consolas"/>
+              </a:rPr>
+              <a:t>VOR JEDER AUSZAHLUNG GEPRÜFT</a:t>
+            </a:r>
+          </a:p>
           <a:p>
             <a:pPr marL="190500" indent="-190500">
               <a:spcBef>
@@ -7464,7 +10498,7 @@
                 </a:solidFill>
                 <a:latin typeface="Arial"/>
               </a:rPr>
-              <a:t>▸  Welche Auszahlungsvoraussetzung wird in Ihrer Praxis am ehesten übersehen?</a:t>
+              <a:t>▸  Kreditvertrag rechtsverbindlich unterschrieben.</a:t>
             </a:r>
           </a:p>
           <a:p>
@@ -7483,7 +10517,7 @@
                 </a:solidFill>
                 <a:latin typeface="Arial"/>
               </a:rPr>
-              <a:t>▸  Woran erkennen Sie, dass eine Sicherheit zwar „vorhanden", aber nicht werthaltig genug ist?</a:t>
+              <a:t>▸  Sicherheiten bestellt und nachgewiesen (Grundschuld eingetragen, Rang gesichert).</a:t>
             </a:r>
           </a:p>
           <a:p>
@@ -7502,7 +10536,26 @@
                 </a:solidFill>
                 <a:latin typeface="Arial"/>
               </a:rPr>
-              <a:t>▸  Wann klären Sie selbst, wann eskalieren Sie an Berater/Marktfolge?</a:t>
+              <a:t>▸  Offenlegungsunterlagen vollständig (§ 18 KWG).</a:t>
+            </a:r>
+          </a:p>
+          <a:p>
+            <a:pPr marL="190500" indent="-190500">
+              <a:spcBef>
+                <a:spcPts val="400"/>
+              </a:spcBef>
+              <a:spcAft>
+                <a:spcPts val="200"/>
+              </a:spcAft>
+            </a:pPr>
+            <a:r>
+              <a:rPr sz="1300">
+                <a:solidFill>
+                  <a:srgbClr val="3D5466"/>
+                </a:solidFill>
+                <a:latin typeface="Arial"/>
+              </a:rPr>
+              <a:t>▸  Besondere Auflagen aus dem Kreditbeschluss erfüllt (z. B. Eigenmittelnachweis).</a:t>
             </a:r>
           </a:p>
         </p:txBody>

</xml_diff>